<commit_message>
Pitch deck: four video slides, drop Meet Finn, add thank-you slide
Slides 4-7 play Sebastien's clips from docs/presentation/video (clip 1
embedded, clips 2-4 placeholders until pushed). The Meet Finn slide is
covered by clip 1; the backup slide becomes a thank-you slide with the
Q&A answers in its notes. Build scripts renamed to .cjs.

Co-Authored-By: Claude Opus 5.5 <noreply@anthropic.com>
</commit_message>
<xml_diff>
--- a/docs/pitch/SDtrust-pitch.pptx
+++ b/docs/pitch/SDtrust-pitch.pptx
@@ -13,9 +13,11 @@
     <p:sldId id="261" r:id="rId7"/>
     <p:sldId id="262" r:id="rId8"/>
     <p:sldId id="263" r:id="rId9"/>
+    <p:sldId id="264" r:id="rId10"/>
+    <p:sldId id="265" r:id="rId11"/>
   </p:sldIdLst>
   <p:notesMasterIdLst>
-    <p:notesMasterId r:id="rId10"/>
+    <p:notesMasterId r:id="rId12"/>
   </p:notesMasterIdLst>
   <p:sldSz cx="12192000" cy="6858000"/>
   <p:notesSz cx="6858000" cy="12192000"/>
@@ -114,36 +116,34 @@
   <p:extLst>
     <p:ext uri="{521415D9-36F7-43E2-AB2F-B90AF26B5E84}">
       <p14:sectionLst xmlns:p14="http://schemas.microsoft.com/office/powerpoint/2010/main">
-        <p14:section name="Problem" id="{3c71b3a2-3fa0-008f-13d5-3081a7f99f13}">
+        <p14:section name="Problem" id="{9798249d-9cf1-c418-31db-ed59db840723}">
           <p14:sldIdLst>
             <p14:sldId id="256"/>
             <p14:sldId id="257"/>
           </p14:sldIdLst>
         </p14:section>
-        <p14:section name="Solution" id="{91c95768-7358-d783-db29-b985224a4a12}">
+        <p14:section name="Solution" id="{6d56a0c0-520e-02b6-54e1-5373d2f09c01}">
           <p14:sldIdLst>
             <p14:sldId id="258"/>
-            <p14:sldId id="259"/>
           </p14:sldIdLst>
         </p14:section>
-        <p14:section name="Demo" id="{8030aedd-af37-59d3-ed81-a2dc48dfc8a0}">
+        <p14:section name="Demo" id="{98493e58-c801-0002-400b-7c0968f4643e}">
           <p14:sldIdLst>
+            <p14:sldId id="259"/>
             <p14:sldId id="260"/>
-          </p14:sldIdLst>
-        </p14:section>
-        <p14:section name="Call" id="{a5a1ca01-facb-e06e-6a89-14ec438a8585}">
-          <p14:sldIdLst>
             <p14:sldId id="261"/>
-          </p14:sldIdLst>
-        </p14:section>
-        <p14:section name="Close" id="{5402e24f-e4f6-9561-71a7-dd6e88c95ded}">
-          <p14:sldIdLst>
             <p14:sldId id="262"/>
           </p14:sldIdLst>
         </p14:section>
-        <p14:section name="Backup" id="{b30dff5f-a5cc-bb6a-49c3-97dca69c79e8}">
+        <p14:section name="Call" id="{2b8078bd-2bbf-c8e7-2e8b-7c9cf30514b5}">
           <p14:sldIdLst>
             <p14:sldId id="263"/>
+          </p14:sldIdLst>
+        </p14:section>
+        <p14:section name="Close" id="{9c24aa10-65af-7685-0e58-1fc2e466b92c}">
+          <p14:sldIdLst>
+            <p14:sldId id="264"/>
+            <p14:sldId id="265"/>
           </p14:sldIdLst>
         </p14:section>
       </p14:sectionLst>
@@ -592,6 +592,96 @@
 </p:notes>
 </file>
 
+<file path=ppt/notesSlides/notesSlide10.xml><?xml version="1.0" encoding="utf-8"?>
+<p:notes xmlns:a="http://schemas.openxmlformats.org/drawingml/2006/main" xmlns:r="http://schemas.openxmlformats.org/officeDocument/2006/relationships" xmlns:p="http://schemas.openxmlformats.org/presentationml/2006/main">
+  <p:cSld>
+    <p:spTree>
+      <p:nvGrpSpPr>
+        <p:cNvPr id="1" name=""/>
+        <p:cNvGrpSpPr/>
+        <p:nvPr/>
+      </p:nvGrpSpPr>
+      <p:grpSpPr>
+        <a:xfrm>
+          <a:off x="0" y="0"/>
+          <a:ext cx="0" cy="0"/>
+          <a:chOff x="0" y="0"/>
+          <a:chExt cx="0" cy="0"/>
+        </a:xfrm>
+      </p:grpSpPr>
+      <p:sp>
+        <p:nvSpPr>
+          <p:cNvPr id="2" name="Slide Image Placeholder 1"/>
+          <p:cNvSpPr>
+            <a:spLocks noGrp="1" noRot="1" noChangeAspect="1"/>
+          </p:cNvSpPr>
+          <p:nvPr>
+            <p:ph type="sldImg"/>
+          </p:nvPr>
+        </p:nvSpPr>
+        <p:spPr/>
+      </p:sp>
+      <p:sp>
+        <p:nvSpPr>
+          <p:cNvPr id="3" name="Notes Placeholder 2"/>
+          <p:cNvSpPr>
+            <a:spLocks noGrp="1"/>
+          </p:cNvSpPr>
+          <p:nvPr>
+            <p:ph type="body" idx="1"/>
+          </p:nvPr>
+        </p:nvSpPr>
+        <p:spPr/>
+        <p:txBody>
+          <a:bodyPr/>
+          <a:lstStyle/>
+          <a:p>
+            <a:r>
+              <a:rPr lang="en-US" dirty="0"/>
+              <a:t>Thank the jury and open for questions.
+If asked how trust is scored: four factors. Authority: an approved statement from the owner beats a proposal or a chat message. Scope: valid for this country, client and period. Validity: superseded or expired versions lose. Agreement: conflicting sources lower trust, and when trust is too low Finn asks the owner.
+If asked whether this is real: the desktop app, the answer and evidence screens and the trust display are built. Sources and the call are simulated with demo data. Connecting Teams, mail and the CRM is the next step.</a:t>
+            </a:r>
+            <a:endParaRPr lang="en-US" dirty="0"/>
+          </a:p>
+        </p:txBody>
+      </p:sp>
+      <p:sp>
+        <p:nvSpPr>
+          <p:cNvPr id="4" name="Slide Number Placeholder 3"/>
+          <p:cNvSpPr>
+            <a:spLocks noGrp="1"/>
+          </p:cNvSpPr>
+          <p:nvPr>
+            <p:ph type="sldNum" sz="quarter" idx="10"/>
+          </p:nvPr>
+        </p:nvSpPr>
+        <p:spPr/>
+        <p:txBody>
+          <a:bodyPr/>
+          <a:lstStyle/>
+          <a:p>
+            <a:fld id="{F7021451-1387-4CA6-816F-3879F97B5CBC}" type="slidenum">
+              <a:rPr lang="en-US"/>
+              <a:t>10</a:t>
+            </a:fld>
+            <a:endParaRPr lang="en-US"/>
+          </a:p>
+        </p:txBody>
+      </p:sp>
+    </p:spTree>
+    <p:extLst>
+      <p:ext uri="{BB962C8B-B14F-4D97-AF65-F5344CB8AC3E}">
+        <p14:creationId xmlns:p14="http://schemas.microsoft.com/office/powerpoint/2010/main" val="1024086991"/>
+      </p:ext>
+    </p:extLst>
+  </p:cSld>
+  <p:clrMapOvr>
+    <a:masterClrMapping/>
+  </p:clrMapOvr>
+</p:notes>
+</file>
+
 <file path=ppt/notesSlides/notesSlide2.xml><?xml version="1.0" encoding="utf-8"?>
 <p:notes xmlns:a="http://schemas.openxmlformats.org/drawingml/2006/main" xmlns:r="http://schemas.openxmlformats.org/officeDocument/2006/relationships" xmlns:p="http://schemas.openxmlformats.org/presentationml/2006/main">
   <p:cSld>
@@ -814,7 +904,7 @@
           <a:p>
             <a:r>
               <a:rPr lang="en-US" dirty="0"/>
-              <a:t>And you talk to SDtrust through Finn. Every answer comes with how much you can trust it and where it came from. And when Finn isn't sure, it says so and asks the colleague who knows.</a:t>
+              <a:t>Video 1: Meet Finn. It plays by itself with its own narration; stay quiet and click when it ends.</a:t>
             </a:r>
             <a:endParaRPr lang="en-US" dirty="0"/>
           </a:p>
@@ -902,15 +992,7 @@
           <a:p>
             <a:r>
               <a:rPr lang="en-US" dirty="0"/>
-              <a:t>Narrate live over the silent video. Cues:
-0:00 Finn idle: Finn lives on your desktop and stays out of the way.
-0:08 Typing the question: Lotte just asks. 'Until when can Atlas submit payroll changes?'
-0:20 Source icons orbit Finn: Finn searches what the company already writes. Teams, mail, CRM, procedures.
-0:30 Answer, 22 October, trust 92%: 22 October, with high trust, and every source behind it.
-0:45 Result page, rejected sources: And it shows what it rejected. The 23rd was a proposal in a meeting. The 25th was a question in chat.
-1:05 Follow-up 'And for next month?': Then Lotte asks about November.
-1:15 Trust 15%, no answer: Most AI would just say 22 October again. Finn says: I don't know. Nothing approved covers November. So Finn calls the one person who does.
-(Video ends around 1:20. Click to the next slide: the call.)</a:t>
+              <a:t>Video 2: Sebastien's clip 2 is not in docs/presentation/video yet. Rebuild the deck once it is pushed.</a:t>
             </a:r>
             <a:endParaRPr lang="en-US" dirty="0"/>
           </a:p>
@@ -998,14 +1080,7 @@
           <a:p>
             <a:r>
               <a:rPr lang="en-US" dirty="0"/>
-              <a:t>THE CALL. Roy stands up holding his phone as if he picks up.
-On entering: the call rings for 2 seconds, then Finn speaks (audio plays by itself):
-  FINN: Hi Roy, it's Finn. You own the Atlas agreements, so you're the one who knows. Until when can Atlas submit payroll changes in November? I can't find anything approved.
-CLICK 1, Roy answers live, loud and clear:
-  ROY: Hi Finn! Until the 24th, same deal as October. I just forgot to put it in the CRM.
-CLICK 2, Finn answers (audio):
-  FINN: Thanks Roy! I've saved it, and I'll let Lotte know.
-CLICK 3, the knowledge card appears. PRESENTER: Roy never opened the CRM. Finn saved his answer from the call, so the next person who asks gets it straight away.</a:t>
+              <a:t>Video 3: Sebastien's clip 3 is not in docs/presentation/video yet. Rebuild the deck once it is pushed.</a:t>
             </a:r>
             <a:endParaRPr lang="en-US" dirty="0"/>
           </a:p>
@@ -1093,7 +1168,7 @@
           <a:p>
             <a:r>
               <a:rPr lang="en-US" dirty="0"/>
-              <a:t>SDtrust: an answer you can trust, or an honest I don't know plus the right colleague. Zero unnecessary effort. Thank you.</a:t>
+              <a:t>Video 4: Sebastien's clip 4 is not in docs/presentation/video yet. Rebuild the deck once it is pushed.</a:t>
             </a:r>
             <a:endParaRPr lang="en-US" dirty="0"/>
           </a:p>
@@ -1181,7 +1256,14 @@
           <a:p>
             <a:r>
               <a:rPr lang="en-US" dirty="0"/>
-              <a:t>Backup for Q&amp;A, question 'How is the trust score calculated?'. Show only if asked.</a:t>
+              <a:t>THE CALL. Roy stands up holding his phone as if he picks up.
+On entering: the call rings for 2 seconds, then Finn speaks (audio plays by itself):
+  FINN: Hi Roy, it's Finn. You own the Atlas agreements, so you're the one who knows. Until when can Atlas submit payroll changes in November? I can't find anything approved.
+CLICK 1, Roy answers live, loud and clear:
+  ROY: Hi Finn! Until the 24th, same deal as October. I just forgot to put it in the CRM.
+CLICK 2, Finn answers (audio):
+  FINN: Thanks Roy! I've saved it, and I'll let Lotte know.
+CLICK 3, the knowledge card appears. PRESENTER: Roy never opened the CRM. Finn saved his answer from the call, so the next person who asks gets it straight away.</a:t>
             </a:r>
             <a:endParaRPr lang="en-US" dirty="0"/>
           </a:p>
@@ -1205,6 +1287,94 @@
             <a:fld id="{F7021451-1387-4CA6-816F-3879F97B5CBC}" type="slidenum">
               <a:rPr lang="en-US"/>
               <a:t>8</a:t>
+            </a:fld>
+            <a:endParaRPr lang="en-US"/>
+          </a:p>
+        </p:txBody>
+      </p:sp>
+    </p:spTree>
+    <p:extLst>
+      <p:ext uri="{BB962C8B-B14F-4D97-AF65-F5344CB8AC3E}">
+        <p14:creationId xmlns:p14="http://schemas.microsoft.com/office/powerpoint/2010/main" val="1024086991"/>
+      </p:ext>
+    </p:extLst>
+  </p:cSld>
+  <p:clrMapOvr>
+    <a:masterClrMapping/>
+  </p:clrMapOvr>
+</p:notes>
+</file>
+
+<file path=ppt/notesSlides/notesSlide9.xml><?xml version="1.0" encoding="utf-8"?>
+<p:notes xmlns:a="http://schemas.openxmlformats.org/drawingml/2006/main" xmlns:r="http://schemas.openxmlformats.org/officeDocument/2006/relationships" xmlns:p="http://schemas.openxmlformats.org/presentationml/2006/main">
+  <p:cSld>
+    <p:spTree>
+      <p:nvGrpSpPr>
+        <p:cNvPr id="1" name=""/>
+        <p:cNvGrpSpPr/>
+        <p:nvPr/>
+      </p:nvGrpSpPr>
+      <p:grpSpPr>
+        <a:xfrm>
+          <a:off x="0" y="0"/>
+          <a:ext cx="0" cy="0"/>
+          <a:chOff x="0" y="0"/>
+          <a:chExt cx="0" cy="0"/>
+        </a:xfrm>
+      </p:grpSpPr>
+      <p:sp>
+        <p:nvSpPr>
+          <p:cNvPr id="2" name="Slide Image Placeholder 1"/>
+          <p:cNvSpPr>
+            <a:spLocks noGrp="1" noRot="1" noChangeAspect="1"/>
+          </p:cNvSpPr>
+          <p:nvPr>
+            <p:ph type="sldImg"/>
+          </p:nvPr>
+        </p:nvSpPr>
+        <p:spPr/>
+      </p:sp>
+      <p:sp>
+        <p:nvSpPr>
+          <p:cNvPr id="3" name="Notes Placeholder 2"/>
+          <p:cNvSpPr>
+            <a:spLocks noGrp="1"/>
+          </p:cNvSpPr>
+          <p:nvPr>
+            <p:ph type="body" idx="1"/>
+          </p:nvPr>
+        </p:nvSpPr>
+        <p:spPr/>
+        <p:txBody>
+          <a:bodyPr/>
+          <a:lstStyle/>
+          <a:p>
+            <a:r>
+              <a:rPr lang="en-US" dirty="0"/>
+              <a:t>SDtrust: an answer you can trust, or an honest I don't know plus the right colleague. Zero unnecessary effort.</a:t>
+            </a:r>
+            <a:endParaRPr lang="en-US" dirty="0"/>
+          </a:p>
+        </p:txBody>
+      </p:sp>
+      <p:sp>
+        <p:nvSpPr>
+          <p:cNvPr id="4" name="Slide Number Placeholder 3"/>
+          <p:cNvSpPr>
+            <a:spLocks noGrp="1"/>
+          </p:cNvSpPr>
+          <p:nvPr>
+            <p:ph type="sldNum" sz="quarter" idx="10"/>
+          </p:nvPr>
+        </p:nvSpPr>
+        <p:spPr/>
+        <p:txBody>
+          <a:bodyPr/>
+          <a:lstStyle/>
+          <a:p>
+            <a:fld id="{F7021451-1387-4CA6-816F-3879F97B5CBC}" type="slidenum">
+              <a:rPr lang="en-US"/>
+              <a:t>9</a:t>
             </a:fld>
             <a:endParaRPr lang="en-US"/>
           </a:p>
@@ -2212,6 +2382,396 @@
 </p:sld>
 </file>
 
+<file path=ppt/slides/slide10.xml><?xml version="1.0" encoding="utf-8"?>
+<p:sld xmlns:a="http://schemas.openxmlformats.org/drawingml/2006/main" xmlns:r="http://schemas.openxmlformats.org/officeDocument/2006/relationships" xmlns:p="http://schemas.openxmlformats.org/presentationml/2006/main">
+  <p:cSld name="Slide 10">
+    <p:spTree>
+      <p:nvGrpSpPr>
+        <p:cNvPr id="1" name=""/>
+        <p:cNvGrpSpPr/>
+        <p:nvPr/>
+      </p:nvGrpSpPr>
+      <p:grpSpPr>
+        <a:xfrm>
+          <a:off x="0" y="0"/>
+          <a:ext cx="0" cy="0"/>
+          <a:chOff x="0" y="0"/>
+          <a:chExt cx="0" cy="0"/>
+        </a:xfrm>
+      </p:grpSpPr>
+      <p:sp>
+        <p:nvSpPr>
+          <p:cNvPr id="2" name="Thanks"/>
+          <p:cNvSpPr txBox="1"/>
+          <p:nvPr/>
+        </p:nvSpPr>
+        <p:spPr>
+          <a:xfrm>
+            <a:off x="731520" y="1447800"/>
+            <a:ext cx="6858000" cy="1066800"/>
+          </a:xfrm>
+          <a:prstGeom prst="rect">
+            <a:avLst/>
+          </a:prstGeom>
+          <a:noFill/>
+          <a:ln/>
+        </p:spPr>
+        <p:txBody>
+          <a:bodyPr wrap="square" lIns="0" tIns="0" rIns="0" bIns="0" rtlCol="0" anchor="t"/>
+          <a:lstStyle/>
+          <a:p>
+            <a:pPr indent="0" marL="0">
+              <a:buNone/>
+            </a:pPr>
+            <a:r>
+              <a:rPr lang="en-US" sz="7200" b="1" dirty="0">
+                <a:solidFill>
+                  <a:schemeClr val="bg1"/>
+                </a:solidFill>
+              </a:rPr>
+              <a:t>Thank you</a:t>
+            </a:r>
+            <a:endParaRPr lang="en-US" sz="7200" dirty="0"/>
+          </a:p>
+        </p:txBody>
+      </p:sp>
+      <p:sp>
+        <p:nvSpPr>
+          <p:cNvPr id="3" name="Questions"/>
+          <p:cNvSpPr txBox="1"/>
+          <p:nvPr/>
+        </p:nvSpPr>
+        <p:spPr>
+          <a:xfrm>
+            <a:off x="731520" y="2667000"/>
+            <a:ext cx="6858000" cy="533400"/>
+          </a:xfrm>
+          <a:prstGeom prst="rect">
+            <a:avLst/>
+          </a:prstGeom>
+          <a:noFill/>
+          <a:ln/>
+        </p:spPr>
+        <p:txBody>
+          <a:bodyPr wrap="square" lIns="0" tIns="0" rIns="0" bIns="0" rtlCol="0" anchor="t"/>
+          <a:lstStyle/>
+          <a:p>
+            <a:pPr indent="0" marL="0">
+              <a:buNone/>
+            </a:pPr>
+            <a:r>
+              <a:rPr lang="en-US" sz="2520" dirty="0">
+                <a:solidFill>
+                  <a:schemeClr val="accent2"/>
+                </a:solidFill>
+              </a:rPr>
+              <a:t>Questions? Finn is listening.</a:t>
+            </a:r>
+            <a:endParaRPr lang="en-US" sz="2520" dirty="0"/>
+          </a:p>
+        </p:txBody>
+      </p:sp>
+      <p:sp>
+        <p:nvSpPr>
+          <p:cNvPr id="4" name="Team"/>
+          <p:cNvSpPr txBox="1"/>
+          <p:nvPr/>
+        </p:nvSpPr>
+        <p:spPr>
+          <a:xfrm>
+            <a:off x="731520" y="4267200"/>
+            <a:ext cx="6096000" cy="274320"/>
+          </a:xfrm>
+          <a:prstGeom prst="rect">
+            <a:avLst/>
+          </a:prstGeom>
+          <a:noFill/>
+          <a:ln/>
+        </p:spPr>
+        <p:txBody>
+          <a:bodyPr wrap="square" lIns="0" tIns="0" rIns="0" bIns="0" rtlCol="0" anchor="t"/>
+          <a:lstStyle/>
+          <a:p>
+            <a:pPr indent="0" marL="0">
+              <a:buNone/>
+            </a:pPr>
+            <a:r>
+              <a:rPr lang="en-US" sz="1200" b="1" dirty="0">
+                <a:solidFill>
+                  <a:schemeClr val="accent2"/>
+                </a:solidFill>
+              </a:rPr>
+              <a:t>Sebastien · Roy · Wanne</a:t>
+            </a:r>
+            <a:endParaRPr lang="en-US" sz="1200" dirty="0"/>
+          </a:p>
+        </p:txBody>
+      </p:sp>
+      <p:sp>
+        <p:nvSpPr>
+          <p:cNvPr id="5" name="Meta"/>
+          <p:cNvSpPr txBox="1"/>
+          <p:nvPr/>
+        </p:nvSpPr>
+        <p:spPr>
+          <a:xfrm>
+            <a:off x="731520" y="4602480"/>
+            <a:ext cx="6858000" cy="228600"/>
+          </a:xfrm>
+          <a:prstGeom prst="rect">
+            <a:avLst/>
+          </a:prstGeom>
+          <a:noFill/>
+          <a:ln/>
+        </p:spPr>
+        <p:txBody>
+          <a:bodyPr wrap="square" lIns="0" tIns="0" rIns="0" bIns="0" rtlCol="0" anchor="t"/>
+          <a:lstStyle/>
+          <a:p>
+            <a:pPr indent="0" marL="0">
+              <a:buNone/>
+            </a:pPr>
+            <a:r>
+              <a:rPr lang="en-US" sz="1020" dirty="0">
+                <a:solidFill>
+                  <a:schemeClr val="bg2"/>
+                </a:solidFill>
+              </a:rPr>
+              <a:t>Tectonic hackathon finals · SD Worx challenge · 20 October 2026</a:t>
+            </a:r>
+            <a:endParaRPr lang="en-US" sz="1020" dirty="0"/>
+          </a:p>
+        </p:txBody>
+      </p:sp>
+      <p:pic>
+        <p:nvPicPr>
+          <p:cNvPr id="6" name="Thanks logo" descr="preencoded.png">    </p:cNvPr>
+          <p:cNvPicPr>
+            <a:picLocks noChangeAspect="1"/>
+          </p:cNvPicPr>
+          <p:nvPr/>
+        </p:nvPicPr>
+        <p:blipFill>
+          <a:blip r:embed="rId1"/>
+          <a:stretch>
+            <a:fillRect/>
+          </a:stretch>
+        </p:blipFill>
+        <p:spPr>
+          <a:xfrm>
+            <a:off x="731520" y="5181600"/>
+            <a:ext cx="548640" cy="548640"/>
+          </a:xfrm>
+          <a:prstGeom prst="rect">
+            <a:avLst/>
+          </a:prstGeom>
+        </p:spPr>
+      </p:pic>
+      <p:sp>
+        <p:nvSpPr>
+          <p:cNvPr id="7" name="Thanks brand"/>
+          <p:cNvSpPr txBox="1"/>
+          <p:nvPr/>
+        </p:nvSpPr>
+        <p:spPr>
+          <a:xfrm>
+            <a:off x="1386840" y="5181600"/>
+            <a:ext cx="3048000" cy="548640"/>
+          </a:xfrm>
+          <a:prstGeom prst="rect">
+            <a:avLst/>
+          </a:prstGeom>
+          <a:noFill/>
+          <a:ln/>
+        </p:spPr>
+        <p:txBody>
+          <a:bodyPr wrap="square" lIns="0" tIns="0" rIns="0" bIns="0" rtlCol="0" anchor="ctr"/>
+          <a:lstStyle/>
+          <a:p>
+            <a:pPr indent="0" marL="0">
+              <a:buNone/>
+            </a:pPr>
+            <a:r>
+              <a:rPr lang="en-US" sz="2040" b="1" dirty="0">
+                <a:solidFill>
+                  <a:schemeClr val="bg1"/>
+                </a:solidFill>
+              </a:rPr>
+              <a:t>SDtrust</a:t>
+            </a:r>
+            <a:endParaRPr lang="en-US" sz="2040" dirty="0"/>
+          </a:p>
+        </p:txBody>
+      </p:sp>
+      <p:pic>
+        <p:nvPicPr>
+          <p:cNvPr id="8" name="Finn waving" descr="/tmp/sdtrust-deck/gifs/finn-waving-big.gif">    </p:cNvPr>
+          <p:cNvPicPr>
+            <a:picLocks noChangeAspect="1"/>
+          </p:cNvPicPr>
+          <p:nvPr/>
+        </p:nvPicPr>
+        <p:blipFill>
+          <a:blip r:embed="rId2"/>
+          <a:stretch>
+            <a:fillRect/>
+          </a:stretch>
+        </p:blipFill>
+        <p:spPr>
+          <a:xfrm>
+            <a:off x="7924800" y="1524000"/>
+            <a:ext cx="2522220" cy="3962400"/>
+          </a:xfrm>
+          <a:prstGeom prst="rect">
+            <a:avLst/>
+          </a:prstGeom>
+        </p:spPr>
+      </p:pic>
+      <p:sp>
+        <p:nvSpPr>
+          <p:cNvPr id="25" name="Slide Number Placeholder 0"/>
+          <p:cNvSpPr>
+            <a:spLocks noGrp="1"/>
+          </p:cNvSpPr>
+          <p:nvPr>
+            <p:ph type="sldNum" sz="quarter" idx="4294967295"/>
+          </p:nvPr>
+        </p:nvSpPr>
+        <p:spPr>
+          <a:xfrm>
+            <a:off x="11338560" y="6355080"/>
+            <a:ext cx="457200" cy="274320"/>
+          </a:xfrm>
+          <a:prstGeom prst="rect">
+            <a:avLst/>
+          </a:prstGeom>
+          <a:extLst>
+            <a:ext uri="{C572A759-6A51-4108-AA02-DFA0A04FC94B}">
+              <ma14:wrappingTextBoxFlag xmlns:ma14="http://schemas.microsoft.com/office/mac/drawingml/2011/main" val="0"/>
+            </a:ext>
+          </a:extLst>
+        </p:spPr>
+        <p:txBody>
+          <a:bodyPr/>
+          <a:lstStyle>
+            <a:lvl1pPr>
+              <a:defRPr sz="900">
+                <a:solidFill>
+                  <a:schemeClr val="accent6"/>
+                </a:solidFill>
+              </a:defRPr>
+            </a:lvl1pPr>
+          </a:lstStyle>
+          <a:p>
+            <a:pPr algn="r"/>
+            <a:fld id="{F7021451-1387-4CA6-816F-3879F97B5CBC}" type="slidenum">
+              <a:rPr b="0" lang="en-US"/>
+              <a:t>10</a:t>
+            </a:fld>
+            <a:endParaRPr lang="en-US"/>
+          </a:p>
+        </p:txBody>
+      </p:sp>
+    </p:spTree>
+  </p:cSld>
+  <p:clrMapOvr>
+    <a:masterClrMapping/>
+  </p:clrMapOvr>
+  <p:transition spd="med">
+    <p:fade/>
+  </p:transition>
+  <p:timing>
+    <p:tnLst>
+      <p:par>
+        <p:cTn id="1" dur="indefinite" restart="never" nodeType="tmRoot">
+          <p:childTnLst>
+            <p:seq concurrent="1" nextAc="seek">
+              <p:cTn id="2" dur="indefinite" nodeType="mainSeq">
+                <p:childTnLst>
+                  <p:par>
+                    <p:cTn id="3" fill="hold">
+                      <p:stCondLst>
+                        <p:cond delay="indefinite"/>
+                        <p:cond evt="onBegin" delay="0">
+                          <p:tn val="2"/>
+                        </p:cond>
+                      </p:stCondLst>
+                      <p:childTnLst>
+                        <p:par>
+                          <p:cTn id="4" fill="hold">
+                            <p:stCondLst>
+                              <p:cond delay="0"/>
+                            </p:stCondLst>
+                            <p:childTnLst>
+                              <p:par>
+                                <p:cTn id="5" presetID="10" presetClass="entr" presetSubtype="0" fill="hold" grpId="0" nodeType="afterEffect">
+                                  <p:stCondLst>
+                                    <p:cond delay="400"/>
+                                  </p:stCondLst>
+                                  <p:childTnLst>
+                                    <p:set>
+                                      <p:cBhvr>
+                                        <p:cTn id="6" dur="1" fill="hold">
+                                          <p:stCondLst>
+                                            <p:cond delay="0"/>
+                                          </p:stCondLst>
+                                        </p:cTn>
+                                        <p:tgtEl>
+                                          <p:spTgt spid="3"/>
+                                        </p:tgtEl>
+                                        <p:attrNameLst>
+                                          <p:attrName>style.visibility</p:attrName>
+                                        </p:attrNameLst>
+                                      </p:cBhvr>
+                                      <p:to>
+                                        <p:strVal val="visible"/>
+                                      </p:to>
+                                    </p:set>
+                                    <p:animEffect transition="in" filter="fade">
+                                      <p:cBhvr>
+                                        <p:cTn id="7" dur="500"/>
+                                        <p:tgtEl>
+                                          <p:spTgt spid="3"/>
+                                        </p:tgtEl>
+                                      </p:cBhvr>
+                                    </p:animEffect>
+                                  </p:childTnLst>
+                                </p:cTn>
+                              </p:par>
+                            </p:childTnLst>
+                          </p:cTn>
+                        </p:par>
+                      </p:childTnLst>
+                    </p:cTn>
+                  </p:par>
+                </p:childTnLst>
+              </p:cTn>
+              <p:prevCondLst>
+                <p:cond evt="onPrev" delay="0">
+                  <p:tgtEl>
+                    <p:sldTgt/>
+                  </p:tgtEl>
+                </p:cond>
+              </p:prevCondLst>
+              <p:nextCondLst>
+                <p:cond evt="onNext" delay="0">
+                  <p:tgtEl>
+                    <p:sldTgt/>
+                  </p:tgtEl>
+                </p:cond>
+              </p:nextCondLst>
+            </p:seq>
+          </p:childTnLst>
+        </p:cTn>
+      </p:par>
+    </p:tnLst>
+    <p:bldLst>
+      <p:bldP spid="3" grpId="0" animBg="1"/>
+    </p:bldLst>
+  </p:timing>
+</p:sld>
+</file>
+
 <file path=ppt/slides/slide2.xml><?xml version="1.0" encoding="utf-8"?>
 <p:sld xmlns:a="http://schemas.openxmlformats.org/drawingml/2006/main" xmlns:r="http://schemas.openxmlformats.org/officeDocument/2006/relationships" xmlns:p="http://schemas.openxmlformats.org/presentationml/2006/main">
   <p:cSld name="Slide 2">
@@ -4593,14 +5153,14 @@
       </p:grpSpPr>
       <p:sp>
         <p:nvSpPr>
-          <p:cNvPr id="2" name="Title"/>
+          <p:cNvPr id="2" name="Clip label"/>
           <p:cNvSpPr txBox="1"/>
           <p:nvPr/>
         </p:nvSpPr>
         <p:spPr>
           <a:xfrm>
-            <a:off x="548640" y="457200"/>
-            <a:ext cx="10668000" cy="609600"/>
+            <a:off x="822960" y="6446520"/>
+            <a:ext cx="6096000" cy="213360"/>
           </a:xfrm>
           <a:prstGeom prst="rect">
             <a:avLst/>
@@ -4616,226 +5176,31 @@
               <a:buNone/>
             </a:pPr>
             <a:r>
-              <a:rPr lang="en-US" sz="3240" b="1" dirty="0">
-                <a:solidFill>
-                  <a:schemeClr val="tx1"/>
+              <a:rPr lang="en-US" sz="1000" b="1" dirty="0">
+                <a:solidFill>
+                  <a:srgbClr val="8FA0B5"/>
                 </a:solidFill>
               </a:rPr>
-              <a:t>Meet Finn</a:t>
-            </a:r>
-            <a:endParaRPr lang="en-US" sz="3240" dirty="0"/>
-          </a:p>
-        </p:txBody>
-      </p:sp>
-      <p:sp>
-        <p:nvSpPr>
-          <p:cNvPr id="3" name="Sub"/>
-          <p:cNvSpPr txBox="1"/>
-          <p:nvPr/>
-        </p:nvSpPr>
-        <p:spPr>
-          <a:xfrm>
-            <a:off x="548640" y="1234440"/>
-            <a:ext cx="4724400" cy="457200"/>
-          </a:xfrm>
-          <a:prstGeom prst="rect">
-            <a:avLst/>
-          </a:prstGeom>
-          <a:noFill/>
-          <a:ln/>
-        </p:spPr>
-        <p:txBody>
-          <a:bodyPr wrap="square" lIns="0" tIns="0" rIns="0" bIns="0" rtlCol="0" anchor="t"/>
-          <a:lstStyle/>
-          <a:p>
-            <a:pPr indent="0" marL="0">
-              <a:buNone/>
-            </a:pPr>
-            <a:r>
-              <a:rPr lang="en-US" sz="1320" dirty="0">
-                <a:solidFill>
-                  <a:schemeClr val="accent6"/>
-                </a:solidFill>
-              </a:rPr>
-              <a:t>Lives on your desktop. Out of the way until you need him.</a:t>
-            </a:r>
-            <a:endParaRPr lang="en-US" sz="1320" dirty="0"/>
+              <a:t>Video 1 · Meet Finn</a:t>
+            </a:r>
+            <a:endParaRPr lang="en-US" sz="1000" dirty="0"/>
           </a:p>
         </p:txBody>
       </p:sp>
       <p:pic>
         <p:nvPicPr>
-          <p:cNvPr id="4" name="Finn idle" descr="/tmp/sdtrust-deck/gifs/finn-idle.gif">    </p:cNvPr>
+          <p:cNvPr id="26" name="Video 1"/>
           <p:cNvPicPr>
             <a:picLocks noChangeAspect="1"/>
           </p:cNvPicPr>
-          <p:nvPr/>
-        </p:nvPicPr>
-        <p:blipFill>
-          <a:blip r:embed="rId1"/>
-          <a:stretch>
-            <a:fillRect/>
-          </a:stretch>
-        </p:blipFill>
-        <p:spPr>
-          <a:xfrm>
-            <a:off x="1447800" y="2057400"/>
-            <a:ext cx="1882140" cy="3810000"/>
-          </a:xfrm>
-          <a:prstGeom prst="rect">
-            <a:avLst/>
-          </a:prstGeom>
-        </p:spPr>
-      </p:pic>
-      <p:sp>
-        <p:nvSpPr>
-          <p:cNvPr id="5" name="Card 0"/>
-          <p:cNvSpPr/>
-          <p:nvPr/>
-        </p:nvSpPr>
-        <p:spPr>
-          <a:xfrm>
-            <a:off x="5486400" y="1417320"/>
-            <a:ext cx="6126480" cy="914400"/>
-          </a:xfrm>
-          <a:prstGeom prst="roundRect">
-            <a:avLst>
-              <a:gd name="adj" fmla="val 15000"/>
-            </a:avLst>
-          </a:prstGeom>
-          <a:solidFill>
-            <a:schemeClr val="bg1"/>
-          </a:solidFill>
-          <a:ln w="12700">
-            <a:solidFill>
-              <a:srgbClr val="E5E1D8"/>
-            </a:solidFill>
-            <a:prstDash val="solid"/>
-          </a:ln>
-          <a:effectLst>
-            <a:outerShdw sx="100000" sy="100000" kx="0" ky="0" algn="bl" rotWithShape="0" blurRad="152400" dist="50800" dir="5400000">
-              <a:srgbClr val="192D46">
-                <a:alpha val="12000"/>
-              </a:srgbClr>
-            </a:outerShdw>
-          </a:effectLst>
-        </p:spPr>
-      </p:sp>
-      <p:pic>
-        <p:nvPicPr>
-          <p:cNvPr id="6" name="Card icon 0" descr="preencoded.png">    </p:cNvPr>
-          <p:cNvPicPr>
-            <a:picLocks noChangeAspect="1"/>
-          </p:cNvPicPr>
-          <p:nvPr/>
-        </p:nvPicPr>
-        <p:blipFill>
-          <a:blip r:embed="rId2"/>
-          <a:stretch>
-            <a:fillRect/>
-          </a:stretch>
-        </p:blipFill>
-        <p:spPr>
-          <a:xfrm>
-            <a:off x="5760720" y="1676400"/>
-            <a:ext cx="396240" cy="396240"/>
-          </a:xfrm>
-          <a:prstGeom prst="rect">
-            <a:avLst/>
-          </a:prstGeom>
-        </p:spPr>
-      </p:pic>
-      <p:sp>
-        <p:nvSpPr>
-          <p:cNvPr id="7" name="Card text 0"/>
-          <p:cNvSpPr txBox="1"/>
-          <p:nvPr/>
-        </p:nvSpPr>
-        <p:spPr>
-          <a:xfrm>
-            <a:off x="6309360" y="1569720"/>
-            <a:ext cx="5105400" cy="640080"/>
-          </a:xfrm>
-          <a:prstGeom prst="rect">
-            <a:avLst/>
-          </a:prstGeom>
-          <a:noFill/>
-          <a:ln/>
-        </p:spPr>
-        <p:txBody>
-          <a:bodyPr wrap="square" lIns="0" tIns="0" rIns="0" bIns="0" rtlCol="0" anchor="ctr"/>
-          <a:lstStyle/>
-          <a:p>
-            <a:pPr indent="0" marL="0">
-              <a:buNone/>
-            </a:pPr>
-            <a:r>
-              <a:rPr lang="en-US" sz="1000" dirty="0">
-                <a:solidFill>
-                  <a:schemeClr val="accent6"/>
-                </a:solidFill>
-              </a:rPr>
-              <a:t>The answer</a:t>
-            </a:r>
-            <a:endParaRPr lang="en-US" sz="1000" dirty="0"/>
-          </a:p>
-          <a:p>
-            <a:pPr indent="0" marL="0">
-              <a:buNone/>
-            </a:pPr>
-            <a:r>
-              <a:rPr lang="en-US" sz="1560" b="1" dirty="0">
-                <a:solidFill>
-                  <a:schemeClr val="tx1"/>
-                </a:solidFill>
-              </a:rPr>
-              <a:t>22 October 2026</a:t>
-            </a:r>
-            <a:endParaRPr lang="en-US" sz="1000" dirty="0"/>
-          </a:p>
-        </p:txBody>
-      </p:sp>
-      <p:sp>
-        <p:nvSpPr>
-          <p:cNvPr id="8" name="Card 1"/>
-          <p:cNvSpPr/>
-          <p:nvPr/>
-        </p:nvSpPr>
-        <p:spPr>
-          <a:xfrm>
-            <a:off x="5486400" y="2514600"/>
-            <a:ext cx="6126480" cy="914400"/>
-          </a:xfrm>
-          <a:prstGeom prst="roundRect">
-            <a:avLst>
-              <a:gd name="adj" fmla="val 15000"/>
-            </a:avLst>
-          </a:prstGeom>
-          <a:solidFill>
-            <a:schemeClr val="bg1"/>
-          </a:solidFill>
-          <a:ln w="12700">
-            <a:solidFill>
-              <a:srgbClr val="E5E1D8"/>
-            </a:solidFill>
-            <a:prstDash val="solid"/>
-          </a:ln>
-          <a:effectLst>
-            <a:outerShdw sx="100000" sy="100000" kx="0" ky="0" algn="bl" rotWithShape="0" blurRad="152400" dist="50800" dir="5400000">
-              <a:srgbClr val="192D46">
-                <a:alpha val="12000"/>
-              </a:srgbClr>
-            </a:outerShdw>
-          </a:effectLst>
-        </p:spPr>
-      </p:sp>
-      <p:pic>
-        <p:nvPicPr>
-          <p:cNvPr id="9" name="Card icon 1" descr="preencoded.png">    </p:cNvPr>
-          <p:cNvPicPr>
-            <a:picLocks noChangeAspect="1"/>
-          </p:cNvPicPr>
-          <p:nvPr/>
+          <p:nvPr>
+            <a:videoFile r:link="rId1"/>
+            <p:extLst>
+              <p:ext uri="{DAA4B4D4-6D71-4841-9C94-3DE7FCFB9230}">
+                <p14:media xmlns:p14="http://schemas.microsoft.com/office/powerpoint/2010/main" r:embed="rId2"/>
+              </p:ext>
+            </p:extLst>
+          </p:nvPr>
         </p:nvPicPr>
         <p:blipFill>
           <a:blip r:embed="rId3"/>
@@ -4845,268 +5210,14 @@
         </p:blipFill>
         <p:spPr>
           <a:xfrm>
-            <a:off x="5760720" y="2773680"/>
-            <a:ext cx="396240" cy="396240"/>
+            <a:off x="822960" y="381000"/>
+            <a:ext cx="10546080" cy="5935980"/>
           </a:xfrm>
           <a:prstGeom prst="rect">
             <a:avLst/>
           </a:prstGeom>
         </p:spPr>
       </p:pic>
-      <p:sp>
-        <p:nvSpPr>
-          <p:cNvPr id="10" name="Card text 1"/>
-          <p:cNvSpPr txBox="1"/>
-          <p:nvPr/>
-        </p:nvSpPr>
-        <p:spPr>
-          <a:xfrm>
-            <a:off x="6309360" y="2667000"/>
-            <a:ext cx="5105400" cy="640080"/>
-          </a:xfrm>
-          <a:prstGeom prst="rect">
-            <a:avLst/>
-          </a:prstGeom>
-          <a:noFill/>
-          <a:ln/>
-        </p:spPr>
-        <p:txBody>
-          <a:bodyPr wrap="square" lIns="0" tIns="0" rIns="0" bIns="0" rtlCol="0" anchor="ctr"/>
-          <a:lstStyle/>
-          <a:p>
-            <a:pPr indent="0" marL="0">
-              <a:buNone/>
-            </a:pPr>
-            <a:r>
-              <a:rPr lang="en-US" sz="1000" dirty="0">
-                <a:solidFill>
-                  <a:schemeClr val="accent6"/>
-                </a:solidFill>
-              </a:rPr>
-              <a:t>How much to trust it</a:t>
-            </a:r>
-            <a:endParaRPr lang="en-US" sz="1000" dirty="0"/>
-          </a:p>
-          <a:p>
-            <a:pPr indent="0" marL="0">
-              <a:buNone/>
-            </a:pPr>
-            <a:r>
-              <a:rPr lang="en-US" sz="1560" b="1" dirty="0">
-                <a:solidFill>
-                  <a:schemeClr val="tx1"/>
-                </a:solidFill>
-              </a:rPr>
-              <a:t>92% · approved by the account owner</a:t>
-            </a:r>
-            <a:endParaRPr lang="en-US" sz="1000" dirty="0"/>
-          </a:p>
-        </p:txBody>
-      </p:sp>
-      <p:sp>
-        <p:nvSpPr>
-          <p:cNvPr id="11" name="Card 2"/>
-          <p:cNvSpPr/>
-          <p:nvPr/>
-        </p:nvSpPr>
-        <p:spPr>
-          <a:xfrm>
-            <a:off x="5486400" y="3611880"/>
-            <a:ext cx="6126480" cy="914400"/>
-          </a:xfrm>
-          <a:prstGeom prst="roundRect">
-            <a:avLst>
-              <a:gd name="adj" fmla="val 15000"/>
-            </a:avLst>
-          </a:prstGeom>
-          <a:solidFill>
-            <a:schemeClr val="bg1"/>
-          </a:solidFill>
-          <a:ln w="12700">
-            <a:solidFill>
-              <a:srgbClr val="E5E1D8"/>
-            </a:solidFill>
-            <a:prstDash val="solid"/>
-          </a:ln>
-          <a:effectLst>
-            <a:outerShdw sx="100000" sy="100000" kx="0" ky="0" algn="bl" rotWithShape="0" blurRad="152400" dist="50800" dir="5400000">
-              <a:srgbClr val="192D46">
-                <a:alpha val="12000"/>
-              </a:srgbClr>
-            </a:outerShdw>
-          </a:effectLst>
-        </p:spPr>
-      </p:sp>
-      <p:pic>
-        <p:nvPicPr>
-          <p:cNvPr id="12" name="Card icon 2" descr="preencoded.png">    </p:cNvPr>
-          <p:cNvPicPr>
-            <a:picLocks noChangeAspect="1"/>
-          </p:cNvPicPr>
-          <p:nvPr/>
-        </p:nvPicPr>
-        <p:blipFill>
-          <a:blip r:embed="rId4"/>
-          <a:stretch>
-            <a:fillRect/>
-          </a:stretch>
-        </p:blipFill>
-        <p:spPr>
-          <a:xfrm>
-            <a:off x="5760720" y="3870960"/>
-            <a:ext cx="396240" cy="396240"/>
-          </a:xfrm>
-          <a:prstGeom prst="rect">
-            <a:avLst/>
-          </a:prstGeom>
-        </p:spPr>
-      </p:pic>
-      <p:sp>
-        <p:nvSpPr>
-          <p:cNvPr id="13" name="Card text 2"/>
-          <p:cNvSpPr txBox="1"/>
-          <p:nvPr/>
-        </p:nvSpPr>
-        <p:spPr>
-          <a:xfrm>
-            <a:off x="6309360" y="3764280"/>
-            <a:ext cx="5105400" cy="640080"/>
-          </a:xfrm>
-          <a:prstGeom prst="rect">
-            <a:avLst/>
-          </a:prstGeom>
-          <a:noFill/>
-          <a:ln/>
-        </p:spPr>
-        <p:txBody>
-          <a:bodyPr wrap="square" lIns="0" tIns="0" rIns="0" bIns="0" rtlCol="0" anchor="ctr"/>
-          <a:lstStyle/>
-          <a:p>
-            <a:pPr indent="0" marL="0">
-              <a:buNone/>
-            </a:pPr>
-            <a:r>
-              <a:rPr lang="en-US" sz="1000" dirty="0">
-                <a:solidFill>
-                  <a:schemeClr val="accent6"/>
-                </a:solidFill>
-              </a:rPr>
-              <a:t>Where it came from</a:t>
-            </a:r>
-            <a:endParaRPr lang="en-US" sz="1000" dirty="0"/>
-          </a:p>
-          <a:p>
-            <a:pPr indent="0" marL="0">
-              <a:buNone/>
-            </a:pPr>
-            <a:r>
-              <a:rPr lang="en-US" sz="1560" b="1" dirty="0">
-                <a:solidFill>
-                  <a:schemeClr val="tx1"/>
-                </a:solidFill>
-              </a:rPr>
-              <a:t>CRM · client agreement · Roy</a:t>
-            </a:r>
-            <a:endParaRPr lang="en-US" sz="1000" dirty="0"/>
-          </a:p>
-        </p:txBody>
-      </p:sp>
-      <p:sp>
-        <p:nvSpPr>
-          <p:cNvPr id="14" name="Card 3"/>
-          <p:cNvSpPr/>
-          <p:nvPr/>
-        </p:nvSpPr>
-        <p:spPr>
-          <a:xfrm>
-            <a:off x="5486400" y="4709160"/>
-            <a:ext cx="6126480" cy="1097280"/>
-          </a:xfrm>
-          <a:prstGeom prst="roundRect">
-            <a:avLst>
-              <a:gd name="adj" fmla="val 12500"/>
-            </a:avLst>
-          </a:prstGeom>
-          <a:solidFill>
-            <a:schemeClr val="accent1"/>
-          </a:solidFill>
-          <a:ln/>
-        </p:spPr>
-      </p:sp>
-      <p:pic>
-        <p:nvPicPr>
-          <p:cNvPr id="15" name="Card icon 3" descr="preencoded.png">    </p:cNvPr>
-          <p:cNvPicPr>
-            <a:picLocks noChangeAspect="1"/>
-          </p:cNvPicPr>
-          <p:nvPr/>
-        </p:nvPicPr>
-        <p:blipFill>
-          <a:blip r:embed="rId5"/>
-          <a:stretch>
-            <a:fillRect/>
-          </a:stretch>
-        </p:blipFill>
-        <p:spPr>
-          <a:xfrm>
-            <a:off x="5760720" y="5059680"/>
-            <a:ext cx="396240" cy="396240"/>
-          </a:xfrm>
-          <a:prstGeom prst="rect">
-            <a:avLst/>
-          </a:prstGeom>
-        </p:spPr>
-      </p:pic>
-      <p:sp>
-        <p:nvSpPr>
-          <p:cNvPr id="16" name="Card text 3"/>
-          <p:cNvSpPr txBox="1"/>
-          <p:nvPr/>
-        </p:nvSpPr>
-        <p:spPr>
-          <a:xfrm>
-            <a:off x="6309360" y="4800600"/>
-            <a:ext cx="5105400" cy="914400"/>
-          </a:xfrm>
-          <a:prstGeom prst="rect">
-            <a:avLst/>
-          </a:prstGeom>
-          <a:noFill/>
-          <a:ln/>
-        </p:spPr>
-        <p:txBody>
-          <a:bodyPr wrap="square" lIns="0" tIns="0" rIns="0" bIns="0" rtlCol="0" anchor="ctr"/>
-          <a:lstStyle/>
-          <a:p>
-            <a:pPr indent="0" marL="0">
-              <a:buNone/>
-            </a:pPr>
-            <a:r>
-              <a:rPr lang="en-US" sz="1000" dirty="0">
-                <a:solidFill>
-                  <a:schemeClr val="bg1"/>
-                </a:solidFill>
-              </a:rPr>
-              <a:t>Not sure?</a:t>
-            </a:r>
-            <a:endParaRPr lang="en-US" sz="1000" dirty="0"/>
-          </a:p>
-          <a:p>
-            <a:pPr indent="0" marL="0">
-              <a:buNone/>
-            </a:pPr>
-            <a:r>
-              <a:rPr lang="en-US" sz="1560" b="1" dirty="0">
-                <a:solidFill>
-                  <a:schemeClr val="bg1"/>
-                </a:solidFill>
-              </a:rPr>
-              <a:t>Finn says so, and asks the colleague who knows</a:t>
-            </a:r>
-            <a:endParaRPr lang="en-US" sz="1000" dirty="0"/>
-          </a:p>
-        </p:txBody>
-      </p:sp>
       <p:sp>
         <p:nvSpPr>
           <p:cNvPr id="25" name="Slide Number Placeholder 0"/>
@@ -5184,878 +5295,19 @@
                             </p:stCondLst>
                             <p:childTnLst>
                               <p:par>
-                                <p:cTn id="5" presetID="2" presetClass="entr" presetSubtype="4" fill="hold" grpId="0" nodeType="afterEffect">
+                                <p:cTn id="5" presetID="1" presetClass="mediacall" presetSubtype="0" fill="hold" nodeType="afterEffect">
                                   <p:stCondLst>
-                                    <p:cond delay="200"/>
+                                    <p:cond delay="0"/>
                                   </p:stCondLst>
                                   <p:childTnLst>
-                                    <p:set>
-                                      <p:cBhvr>
-                                        <p:cTn id="6" dur="1" fill="hold">
-                                          <p:stCondLst>
-                                            <p:cond delay="0"/>
-                                          </p:stCondLst>
-                                        </p:cTn>
-                                        <p:tgtEl>
-                                          <p:spTgt spid="5"/>
-                                        </p:tgtEl>
-                                        <p:attrNameLst>
-                                          <p:attrName>style.visibility</p:attrName>
-                                        </p:attrNameLst>
-                                      </p:cBhvr>
-                                      <p:to>
-                                        <p:strVal val="visible"/>
-                                      </p:to>
-                                    </p:set>
-                                    <p:anim calcmode="lin" valueType="num">
-                                      <p:cBhvr additive="base">
-                                        <p:cTn id="7" dur="500" fill="hold"/>
-                                        <p:tgtEl>
-                                          <p:spTgt spid="5"/>
-                                        </p:tgtEl>
-                                        <p:attrNameLst>
-                                          <p:attrName>ppt_x</p:attrName>
-                                        </p:attrNameLst>
-                                      </p:cBhvr>
-                                      <p:tavLst>
-                                        <p:tav tm="0">
-                                          <p:val>
-                                            <p:strVal val="#ppt_x"/>
-                                          </p:val>
-                                        </p:tav>
-                                        <p:tav tm="100000">
-                                          <p:val>
-                                            <p:strVal val="#ppt_x"/>
-                                          </p:val>
-                                        </p:tav>
-                                      </p:tavLst>
-                                    </p:anim>
-                                    <p:anim calcmode="lin" valueType="num">
-                                      <p:cBhvr additive="base">
-                                        <p:cTn id="8" dur="500" fill="hold"/>
-                                        <p:tgtEl>
-                                          <p:spTgt spid="5"/>
-                                        </p:tgtEl>
-                                        <p:attrNameLst>
-                                          <p:attrName>ppt_y</p:attrName>
-                                        </p:attrNameLst>
-                                      </p:cBhvr>
-                                      <p:tavLst>
-                                        <p:tav tm="0">
-                                          <p:val>
-                                            <p:strVal val="1+#ppt_h/2"/>
-                                          </p:val>
-                                        </p:tav>
-                                        <p:tav tm="100000">
-                                          <p:val>
-                                            <p:strVal val="#ppt_y"/>
-                                          </p:val>
-                                        </p:tav>
-                                      </p:tavLst>
-                                    </p:anim>
-                                  </p:childTnLst>
-                                </p:cTn>
-                              </p:par>
-                              <p:par>
-                                <p:cTn id="9" presetID="2" presetClass="entr" presetSubtype="4" fill="hold" grpId="0" nodeType="withEffect">
-                                  <p:stCondLst>
-                                    <p:cond delay="200"/>
-                                  </p:stCondLst>
-                                  <p:childTnLst>
-                                    <p:set>
-                                      <p:cBhvr>
-                                        <p:cTn id="10" dur="1" fill="hold">
-                                          <p:stCondLst>
-                                            <p:cond delay="0"/>
-                                          </p:stCondLst>
-                                        </p:cTn>
-                                        <p:tgtEl>
-                                          <p:spTgt spid="6"/>
-                                        </p:tgtEl>
-                                        <p:attrNameLst>
-                                          <p:attrName>style.visibility</p:attrName>
-                                        </p:attrNameLst>
-                                      </p:cBhvr>
-                                      <p:to>
-                                        <p:strVal val="visible"/>
-                                      </p:to>
-                                    </p:set>
-                                    <p:anim calcmode="lin" valueType="num">
-                                      <p:cBhvr additive="base">
-                                        <p:cTn id="11" dur="500" fill="hold"/>
-                                        <p:tgtEl>
-                                          <p:spTgt spid="6"/>
-                                        </p:tgtEl>
-                                        <p:attrNameLst>
-                                          <p:attrName>ppt_x</p:attrName>
-                                        </p:attrNameLst>
-                                      </p:cBhvr>
-                                      <p:tavLst>
-                                        <p:tav tm="0">
-                                          <p:val>
-                                            <p:strVal val="#ppt_x"/>
-                                          </p:val>
-                                        </p:tav>
-                                        <p:tav tm="100000">
-                                          <p:val>
-                                            <p:strVal val="#ppt_x"/>
-                                          </p:val>
-                                        </p:tav>
-                                      </p:tavLst>
-                                    </p:anim>
-                                    <p:anim calcmode="lin" valueType="num">
-                                      <p:cBhvr additive="base">
-                                        <p:cTn id="12" dur="500" fill="hold"/>
-                                        <p:tgtEl>
-                                          <p:spTgt spid="6"/>
-                                        </p:tgtEl>
-                                        <p:attrNameLst>
-                                          <p:attrName>ppt_y</p:attrName>
-                                        </p:attrNameLst>
-                                      </p:cBhvr>
-                                      <p:tavLst>
-                                        <p:tav tm="0">
-                                          <p:val>
-                                            <p:strVal val="1+#ppt_h/2"/>
-                                          </p:val>
-                                        </p:tav>
-                                        <p:tav tm="100000">
-                                          <p:val>
-                                            <p:strVal val="#ppt_y"/>
-                                          </p:val>
-                                        </p:tav>
-                                      </p:tavLst>
-                                    </p:anim>
-                                  </p:childTnLst>
-                                </p:cTn>
-                              </p:par>
-                              <p:par>
-                                <p:cTn id="13" presetID="2" presetClass="entr" presetSubtype="4" fill="hold" grpId="0" nodeType="withEffect">
-                                  <p:stCondLst>
-                                    <p:cond delay="200"/>
-                                  </p:stCondLst>
-                                  <p:childTnLst>
-                                    <p:set>
-                                      <p:cBhvr>
-                                        <p:cTn id="14" dur="1" fill="hold">
-                                          <p:stCondLst>
-                                            <p:cond delay="0"/>
-                                          </p:stCondLst>
-                                        </p:cTn>
-                                        <p:tgtEl>
-                                          <p:spTgt spid="7"/>
-                                        </p:tgtEl>
-                                        <p:attrNameLst>
-                                          <p:attrName>style.visibility</p:attrName>
-                                        </p:attrNameLst>
-                                      </p:cBhvr>
-                                      <p:to>
-                                        <p:strVal val="visible"/>
-                                      </p:to>
-                                    </p:set>
-                                    <p:anim calcmode="lin" valueType="num">
-                                      <p:cBhvr additive="base">
-                                        <p:cTn id="15" dur="500" fill="hold"/>
-                                        <p:tgtEl>
-                                          <p:spTgt spid="7"/>
-                                        </p:tgtEl>
-                                        <p:attrNameLst>
-                                          <p:attrName>ppt_x</p:attrName>
-                                        </p:attrNameLst>
-                                      </p:cBhvr>
-                                      <p:tavLst>
-                                        <p:tav tm="0">
-                                          <p:val>
-                                            <p:strVal val="#ppt_x"/>
-                                          </p:val>
-                                        </p:tav>
-                                        <p:tav tm="100000">
-                                          <p:val>
-                                            <p:strVal val="#ppt_x"/>
-                                          </p:val>
-                                        </p:tav>
-                                      </p:tavLst>
-                                    </p:anim>
-                                    <p:anim calcmode="lin" valueType="num">
-                                      <p:cBhvr additive="base">
-                                        <p:cTn id="16" dur="500" fill="hold"/>
-                                        <p:tgtEl>
-                                          <p:spTgt spid="7"/>
-                                        </p:tgtEl>
-                                        <p:attrNameLst>
-                                          <p:attrName>ppt_y</p:attrName>
-                                        </p:attrNameLst>
-                                      </p:cBhvr>
-                                      <p:tavLst>
-                                        <p:tav tm="0">
-                                          <p:val>
-                                            <p:strVal val="1+#ppt_h/2"/>
-                                          </p:val>
-                                        </p:tav>
-                                        <p:tav tm="100000">
-                                          <p:val>
-                                            <p:strVal val="#ppt_y"/>
-                                          </p:val>
-                                        </p:tav>
-                                      </p:tavLst>
-                                    </p:anim>
-                                  </p:childTnLst>
-                                </p:cTn>
-                              </p:par>
-                              <p:par>
-                                <p:cTn id="17" presetID="2" presetClass="entr" presetSubtype="4" fill="hold" grpId="0" nodeType="withEffect">
-                                  <p:stCondLst>
-                                    <p:cond delay="450"/>
-                                  </p:stCondLst>
-                                  <p:childTnLst>
-                                    <p:set>
-                                      <p:cBhvr>
-                                        <p:cTn id="18" dur="1" fill="hold">
-                                          <p:stCondLst>
-                                            <p:cond delay="0"/>
-                                          </p:stCondLst>
-                                        </p:cTn>
-                                        <p:tgtEl>
-                                          <p:spTgt spid="8"/>
-                                        </p:tgtEl>
-                                        <p:attrNameLst>
-                                          <p:attrName>style.visibility</p:attrName>
-                                        </p:attrNameLst>
-                                      </p:cBhvr>
-                                      <p:to>
-                                        <p:strVal val="visible"/>
-                                      </p:to>
-                                    </p:set>
-                                    <p:anim calcmode="lin" valueType="num">
-                                      <p:cBhvr additive="base">
-                                        <p:cTn id="19" dur="500" fill="hold"/>
-                                        <p:tgtEl>
-                                          <p:spTgt spid="8"/>
-                                        </p:tgtEl>
-                                        <p:attrNameLst>
-                                          <p:attrName>ppt_x</p:attrName>
-                                        </p:attrNameLst>
-                                      </p:cBhvr>
-                                      <p:tavLst>
-                                        <p:tav tm="0">
-                                          <p:val>
-                                            <p:strVal val="#ppt_x"/>
-                                          </p:val>
-                                        </p:tav>
-                                        <p:tav tm="100000">
-                                          <p:val>
-                                            <p:strVal val="#ppt_x"/>
-                                          </p:val>
-                                        </p:tav>
-                                      </p:tavLst>
-                                    </p:anim>
-                                    <p:anim calcmode="lin" valueType="num">
-                                      <p:cBhvr additive="base">
-                                        <p:cTn id="20" dur="500" fill="hold"/>
-                                        <p:tgtEl>
-                                          <p:spTgt spid="8"/>
-                                        </p:tgtEl>
-                                        <p:attrNameLst>
-                                          <p:attrName>ppt_y</p:attrName>
-                                        </p:attrNameLst>
-                                      </p:cBhvr>
-                                      <p:tavLst>
-                                        <p:tav tm="0">
-                                          <p:val>
-                                            <p:strVal val="1+#ppt_h/2"/>
-                                          </p:val>
-                                        </p:tav>
-                                        <p:tav tm="100000">
-                                          <p:val>
-                                            <p:strVal val="#ppt_y"/>
-                                          </p:val>
-                                        </p:tav>
-                                      </p:tavLst>
-                                    </p:anim>
-                                  </p:childTnLst>
-                                </p:cTn>
-                              </p:par>
-                              <p:par>
-                                <p:cTn id="21" presetID="2" presetClass="entr" presetSubtype="4" fill="hold" grpId="0" nodeType="withEffect">
-                                  <p:stCondLst>
-                                    <p:cond delay="450"/>
-                                  </p:stCondLst>
-                                  <p:childTnLst>
-                                    <p:set>
-                                      <p:cBhvr>
-                                        <p:cTn id="22" dur="1" fill="hold">
-                                          <p:stCondLst>
-                                            <p:cond delay="0"/>
-                                          </p:stCondLst>
-                                        </p:cTn>
-                                        <p:tgtEl>
-                                          <p:spTgt spid="9"/>
-                                        </p:tgtEl>
-                                        <p:attrNameLst>
-                                          <p:attrName>style.visibility</p:attrName>
-                                        </p:attrNameLst>
-                                      </p:cBhvr>
-                                      <p:to>
-                                        <p:strVal val="visible"/>
-                                      </p:to>
-                                    </p:set>
-                                    <p:anim calcmode="lin" valueType="num">
-                                      <p:cBhvr additive="base">
-                                        <p:cTn id="23" dur="500" fill="hold"/>
-                                        <p:tgtEl>
-                                          <p:spTgt spid="9"/>
-                                        </p:tgtEl>
-                                        <p:attrNameLst>
-                                          <p:attrName>ppt_x</p:attrName>
-                                        </p:attrNameLst>
-                                      </p:cBhvr>
-                                      <p:tavLst>
-                                        <p:tav tm="0">
-                                          <p:val>
-                                            <p:strVal val="#ppt_x"/>
-                                          </p:val>
-                                        </p:tav>
-                                        <p:tav tm="100000">
-                                          <p:val>
-                                            <p:strVal val="#ppt_x"/>
-                                          </p:val>
-                                        </p:tav>
-                                      </p:tavLst>
-                                    </p:anim>
-                                    <p:anim calcmode="lin" valueType="num">
-                                      <p:cBhvr additive="base">
-                                        <p:cTn id="24" dur="500" fill="hold"/>
-                                        <p:tgtEl>
-                                          <p:spTgt spid="9"/>
-                                        </p:tgtEl>
-                                        <p:attrNameLst>
-                                          <p:attrName>ppt_y</p:attrName>
-                                        </p:attrNameLst>
-                                      </p:cBhvr>
-                                      <p:tavLst>
-                                        <p:tav tm="0">
-                                          <p:val>
-                                            <p:strVal val="1+#ppt_h/2"/>
-                                          </p:val>
-                                        </p:tav>
-                                        <p:tav tm="100000">
-                                          <p:val>
-                                            <p:strVal val="#ppt_y"/>
-                                          </p:val>
-                                        </p:tav>
-                                      </p:tavLst>
-                                    </p:anim>
-                                  </p:childTnLst>
-                                </p:cTn>
-                              </p:par>
-                              <p:par>
-                                <p:cTn id="25" presetID="2" presetClass="entr" presetSubtype="4" fill="hold" grpId="0" nodeType="withEffect">
-                                  <p:stCondLst>
-                                    <p:cond delay="450"/>
-                                  </p:stCondLst>
-                                  <p:childTnLst>
-                                    <p:set>
-                                      <p:cBhvr>
-                                        <p:cTn id="26" dur="1" fill="hold">
-                                          <p:stCondLst>
-                                            <p:cond delay="0"/>
-                                          </p:stCondLst>
-                                        </p:cTn>
-                                        <p:tgtEl>
-                                          <p:spTgt spid="10"/>
-                                        </p:tgtEl>
-                                        <p:attrNameLst>
-                                          <p:attrName>style.visibility</p:attrName>
-                                        </p:attrNameLst>
-                                      </p:cBhvr>
-                                      <p:to>
-                                        <p:strVal val="visible"/>
-                                      </p:to>
-                                    </p:set>
-                                    <p:anim calcmode="lin" valueType="num">
-                                      <p:cBhvr additive="base">
-                                        <p:cTn id="27" dur="500" fill="hold"/>
-                                        <p:tgtEl>
-                                          <p:spTgt spid="10"/>
-                                        </p:tgtEl>
-                                        <p:attrNameLst>
-                                          <p:attrName>ppt_x</p:attrName>
-                                        </p:attrNameLst>
-                                      </p:cBhvr>
-                                      <p:tavLst>
-                                        <p:tav tm="0">
-                                          <p:val>
-                                            <p:strVal val="#ppt_x"/>
-                                          </p:val>
-                                        </p:tav>
-                                        <p:tav tm="100000">
-                                          <p:val>
-                                            <p:strVal val="#ppt_x"/>
-                                          </p:val>
-                                        </p:tav>
-                                      </p:tavLst>
-                                    </p:anim>
-                                    <p:anim calcmode="lin" valueType="num">
-                                      <p:cBhvr additive="base">
-                                        <p:cTn id="28" dur="500" fill="hold"/>
-                                        <p:tgtEl>
-                                          <p:spTgt spid="10"/>
-                                        </p:tgtEl>
-                                        <p:attrNameLst>
-                                          <p:attrName>ppt_y</p:attrName>
-                                        </p:attrNameLst>
-                                      </p:cBhvr>
-                                      <p:tavLst>
-                                        <p:tav tm="0">
-                                          <p:val>
-                                            <p:strVal val="1+#ppt_h/2"/>
-                                          </p:val>
-                                        </p:tav>
-                                        <p:tav tm="100000">
-                                          <p:val>
-                                            <p:strVal val="#ppt_y"/>
-                                          </p:val>
-                                        </p:tav>
-                                      </p:tavLst>
-                                    </p:anim>
-                                  </p:childTnLst>
-                                </p:cTn>
-                              </p:par>
-                              <p:par>
-                                <p:cTn id="29" presetID="2" presetClass="entr" presetSubtype="4" fill="hold" grpId="0" nodeType="withEffect">
-                                  <p:stCondLst>
-                                    <p:cond delay="700"/>
-                                  </p:stCondLst>
-                                  <p:childTnLst>
-                                    <p:set>
-                                      <p:cBhvr>
-                                        <p:cTn id="30" dur="1" fill="hold">
-                                          <p:stCondLst>
-                                            <p:cond delay="0"/>
-                                          </p:stCondLst>
-                                        </p:cTn>
-                                        <p:tgtEl>
-                                          <p:spTgt spid="11"/>
-                                        </p:tgtEl>
-                                        <p:attrNameLst>
-                                          <p:attrName>style.visibility</p:attrName>
-                                        </p:attrNameLst>
-                                      </p:cBhvr>
-                                      <p:to>
-                                        <p:strVal val="visible"/>
-                                      </p:to>
-                                    </p:set>
-                                    <p:anim calcmode="lin" valueType="num">
-                                      <p:cBhvr additive="base">
-                                        <p:cTn id="31" dur="500" fill="hold"/>
-                                        <p:tgtEl>
-                                          <p:spTgt spid="11"/>
-                                        </p:tgtEl>
-                                        <p:attrNameLst>
-                                          <p:attrName>ppt_x</p:attrName>
-                                        </p:attrNameLst>
-                                      </p:cBhvr>
-                                      <p:tavLst>
-                                        <p:tav tm="0">
-                                          <p:val>
-                                            <p:strVal val="#ppt_x"/>
-                                          </p:val>
-                                        </p:tav>
-                                        <p:tav tm="100000">
-                                          <p:val>
-                                            <p:strVal val="#ppt_x"/>
-                                          </p:val>
-                                        </p:tav>
-                                      </p:tavLst>
-                                    </p:anim>
-                                    <p:anim calcmode="lin" valueType="num">
-                                      <p:cBhvr additive="base">
-                                        <p:cTn id="32" dur="500" fill="hold"/>
-                                        <p:tgtEl>
-                                          <p:spTgt spid="11"/>
-                                        </p:tgtEl>
-                                        <p:attrNameLst>
-                                          <p:attrName>ppt_y</p:attrName>
-                                        </p:attrNameLst>
-                                      </p:cBhvr>
-                                      <p:tavLst>
-                                        <p:tav tm="0">
-                                          <p:val>
-                                            <p:strVal val="1+#ppt_h/2"/>
-                                          </p:val>
-                                        </p:tav>
-                                        <p:tav tm="100000">
-                                          <p:val>
-                                            <p:strVal val="#ppt_y"/>
-                                          </p:val>
-                                        </p:tav>
-                                      </p:tavLst>
-                                    </p:anim>
-                                  </p:childTnLst>
-                                </p:cTn>
-                              </p:par>
-                              <p:par>
-                                <p:cTn id="33" presetID="2" presetClass="entr" presetSubtype="4" fill="hold" grpId="0" nodeType="withEffect">
-                                  <p:stCondLst>
-                                    <p:cond delay="700"/>
-                                  </p:stCondLst>
-                                  <p:childTnLst>
-                                    <p:set>
-                                      <p:cBhvr>
-                                        <p:cTn id="34" dur="1" fill="hold">
-                                          <p:stCondLst>
-                                            <p:cond delay="0"/>
-                                          </p:stCondLst>
-                                        </p:cTn>
-                                        <p:tgtEl>
-                                          <p:spTgt spid="12"/>
-                                        </p:tgtEl>
-                                        <p:attrNameLst>
-                                          <p:attrName>style.visibility</p:attrName>
-                                        </p:attrNameLst>
-                                      </p:cBhvr>
-                                      <p:to>
-                                        <p:strVal val="visible"/>
-                                      </p:to>
-                                    </p:set>
-                                    <p:anim calcmode="lin" valueType="num">
-                                      <p:cBhvr additive="base">
-                                        <p:cTn id="35" dur="500" fill="hold"/>
-                                        <p:tgtEl>
-                                          <p:spTgt spid="12"/>
-                                        </p:tgtEl>
-                                        <p:attrNameLst>
-                                          <p:attrName>ppt_x</p:attrName>
-                                        </p:attrNameLst>
-                                      </p:cBhvr>
-                                      <p:tavLst>
-                                        <p:tav tm="0">
-                                          <p:val>
-                                            <p:strVal val="#ppt_x"/>
-                                          </p:val>
-                                        </p:tav>
-                                        <p:tav tm="100000">
-                                          <p:val>
-                                            <p:strVal val="#ppt_x"/>
-                                          </p:val>
-                                        </p:tav>
-                                      </p:tavLst>
-                                    </p:anim>
-                                    <p:anim calcmode="lin" valueType="num">
-                                      <p:cBhvr additive="base">
-                                        <p:cTn id="36" dur="500" fill="hold"/>
-                                        <p:tgtEl>
-                                          <p:spTgt spid="12"/>
-                                        </p:tgtEl>
-                                        <p:attrNameLst>
-                                          <p:attrName>ppt_y</p:attrName>
-                                        </p:attrNameLst>
-                                      </p:cBhvr>
-                                      <p:tavLst>
-                                        <p:tav tm="0">
-                                          <p:val>
-                                            <p:strVal val="1+#ppt_h/2"/>
-                                          </p:val>
-                                        </p:tav>
-                                        <p:tav tm="100000">
-                                          <p:val>
-                                            <p:strVal val="#ppt_y"/>
-                                          </p:val>
-                                        </p:tav>
-                                      </p:tavLst>
-                                    </p:anim>
-                                  </p:childTnLst>
-                                </p:cTn>
-                              </p:par>
-                              <p:par>
-                                <p:cTn id="37" presetID="2" presetClass="entr" presetSubtype="4" fill="hold" grpId="0" nodeType="withEffect">
-                                  <p:stCondLst>
-                                    <p:cond delay="700"/>
-                                  </p:stCondLst>
-                                  <p:childTnLst>
-                                    <p:set>
-                                      <p:cBhvr>
-                                        <p:cTn id="38" dur="1" fill="hold">
-                                          <p:stCondLst>
-                                            <p:cond delay="0"/>
-                                          </p:stCondLst>
-                                        </p:cTn>
-                                        <p:tgtEl>
-                                          <p:spTgt spid="13"/>
-                                        </p:tgtEl>
-                                        <p:attrNameLst>
-                                          <p:attrName>style.visibility</p:attrName>
-                                        </p:attrNameLst>
-                                      </p:cBhvr>
-                                      <p:to>
-                                        <p:strVal val="visible"/>
-                                      </p:to>
-                                    </p:set>
-                                    <p:anim calcmode="lin" valueType="num">
-                                      <p:cBhvr additive="base">
-                                        <p:cTn id="39" dur="500" fill="hold"/>
-                                        <p:tgtEl>
-                                          <p:spTgt spid="13"/>
-                                        </p:tgtEl>
-                                        <p:attrNameLst>
-                                          <p:attrName>ppt_x</p:attrName>
-                                        </p:attrNameLst>
-                                      </p:cBhvr>
-                                      <p:tavLst>
-                                        <p:tav tm="0">
-                                          <p:val>
-                                            <p:strVal val="#ppt_x"/>
-                                          </p:val>
-                                        </p:tav>
-                                        <p:tav tm="100000">
-                                          <p:val>
-                                            <p:strVal val="#ppt_x"/>
-                                          </p:val>
-                                        </p:tav>
-                                      </p:tavLst>
-                                    </p:anim>
-                                    <p:anim calcmode="lin" valueType="num">
-                                      <p:cBhvr additive="base">
-                                        <p:cTn id="40" dur="500" fill="hold"/>
-                                        <p:tgtEl>
-                                          <p:spTgt spid="13"/>
-                                        </p:tgtEl>
-                                        <p:attrNameLst>
-                                          <p:attrName>ppt_y</p:attrName>
-                                        </p:attrNameLst>
-                                      </p:cBhvr>
-                                      <p:tavLst>
-                                        <p:tav tm="0">
-                                          <p:val>
-                                            <p:strVal val="1+#ppt_h/2"/>
-                                          </p:val>
-                                        </p:tav>
-                                        <p:tav tm="100000">
-                                          <p:val>
-                                            <p:strVal val="#ppt_y"/>
-                                          </p:val>
-                                        </p:tav>
-                                      </p:tavLst>
-                                    </p:anim>
-                                  </p:childTnLst>
-                                </p:cTn>
-                              </p:par>
-                              <p:par>
-                                <p:cTn id="41" presetID="2" presetClass="entr" presetSubtype="4" fill="hold" grpId="0" nodeType="withEffect">
-                                  <p:stCondLst>
-                                    <p:cond delay="1000"/>
-                                  </p:stCondLst>
-                                  <p:childTnLst>
-                                    <p:set>
-                                      <p:cBhvr>
-                                        <p:cTn id="42" dur="1" fill="hold">
-                                          <p:stCondLst>
-                                            <p:cond delay="0"/>
-                                          </p:stCondLst>
-                                        </p:cTn>
-                                        <p:tgtEl>
-                                          <p:spTgt spid="14"/>
-                                        </p:tgtEl>
-                                        <p:attrNameLst>
-                                          <p:attrName>style.visibility</p:attrName>
-                                        </p:attrNameLst>
-                                      </p:cBhvr>
-                                      <p:to>
-                                        <p:strVal val="visible"/>
-                                      </p:to>
-                                    </p:set>
-                                    <p:anim calcmode="lin" valueType="num">
-                                      <p:cBhvr additive="base">
-                                        <p:cTn id="43" dur="500" fill="hold"/>
-                                        <p:tgtEl>
-                                          <p:spTgt spid="14"/>
-                                        </p:tgtEl>
-                                        <p:attrNameLst>
-                                          <p:attrName>ppt_x</p:attrName>
-                                        </p:attrNameLst>
-                                      </p:cBhvr>
-                                      <p:tavLst>
-                                        <p:tav tm="0">
-                                          <p:val>
-                                            <p:strVal val="#ppt_x"/>
-                                          </p:val>
-                                        </p:tav>
-                                        <p:tav tm="100000">
-                                          <p:val>
-                                            <p:strVal val="#ppt_x"/>
-                                          </p:val>
-                                        </p:tav>
-                                      </p:tavLst>
-                                    </p:anim>
-                                    <p:anim calcmode="lin" valueType="num">
-                                      <p:cBhvr additive="base">
-                                        <p:cTn id="44" dur="500" fill="hold"/>
-                                        <p:tgtEl>
-                                          <p:spTgt spid="14"/>
-                                        </p:tgtEl>
-                                        <p:attrNameLst>
-                                          <p:attrName>ppt_y</p:attrName>
-                                        </p:attrNameLst>
-                                      </p:cBhvr>
-                                      <p:tavLst>
-                                        <p:tav tm="0">
-                                          <p:val>
-                                            <p:strVal val="1+#ppt_h/2"/>
-                                          </p:val>
-                                        </p:tav>
-                                        <p:tav tm="100000">
-                                          <p:val>
-                                            <p:strVal val="#ppt_y"/>
-                                          </p:val>
-                                        </p:tav>
-                                      </p:tavLst>
-                                    </p:anim>
-                                  </p:childTnLst>
-                                </p:cTn>
-                              </p:par>
-                              <p:par>
-                                <p:cTn id="45" presetID="2" presetClass="entr" presetSubtype="4" fill="hold" grpId="0" nodeType="withEffect">
-                                  <p:stCondLst>
-                                    <p:cond delay="1000"/>
-                                  </p:stCondLst>
-                                  <p:childTnLst>
-                                    <p:set>
-                                      <p:cBhvr>
-                                        <p:cTn id="46" dur="1" fill="hold">
-                                          <p:stCondLst>
-                                            <p:cond delay="0"/>
-                                          </p:stCondLst>
-                                        </p:cTn>
-                                        <p:tgtEl>
-                                          <p:spTgt spid="15"/>
-                                        </p:tgtEl>
-                                        <p:attrNameLst>
-                                          <p:attrName>style.visibility</p:attrName>
-                                        </p:attrNameLst>
-                                      </p:cBhvr>
-                                      <p:to>
-                                        <p:strVal val="visible"/>
-                                      </p:to>
-                                    </p:set>
-                                    <p:anim calcmode="lin" valueType="num">
-                                      <p:cBhvr additive="base">
-                                        <p:cTn id="47" dur="500" fill="hold"/>
-                                        <p:tgtEl>
-                                          <p:spTgt spid="15"/>
-                                        </p:tgtEl>
-                                        <p:attrNameLst>
-                                          <p:attrName>ppt_x</p:attrName>
-                                        </p:attrNameLst>
-                                      </p:cBhvr>
-                                      <p:tavLst>
-                                        <p:tav tm="0">
-                                          <p:val>
-                                            <p:strVal val="#ppt_x"/>
-                                          </p:val>
-                                        </p:tav>
-                                        <p:tav tm="100000">
-                                          <p:val>
-                                            <p:strVal val="#ppt_x"/>
-                                          </p:val>
-                                        </p:tav>
-                                      </p:tavLst>
-                                    </p:anim>
-                                    <p:anim calcmode="lin" valueType="num">
-                                      <p:cBhvr additive="base">
-                                        <p:cTn id="48" dur="500" fill="hold"/>
-                                        <p:tgtEl>
-                                          <p:spTgt spid="15"/>
-                                        </p:tgtEl>
-                                        <p:attrNameLst>
-                                          <p:attrName>ppt_y</p:attrName>
-                                        </p:attrNameLst>
-                                      </p:cBhvr>
-                                      <p:tavLst>
-                                        <p:tav tm="0">
-                                          <p:val>
-                                            <p:strVal val="1+#ppt_h/2"/>
-                                          </p:val>
-                                        </p:tav>
-                                        <p:tav tm="100000">
-                                          <p:val>
-                                            <p:strVal val="#ppt_y"/>
-                                          </p:val>
-                                        </p:tav>
-                                      </p:tavLst>
-                                    </p:anim>
-                                  </p:childTnLst>
-                                </p:cTn>
-                              </p:par>
-                              <p:par>
-                                <p:cTn id="49" presetID="2" presetClass="entr" presetSubtype="4" fill="hold" grpId="0" nodeType="withEffect">
-                                  <p:stCondLst>
-                                    <p:cond delay="1000"/>
-                                  </p:stCondLst>
-                                  <p:childTnLst>
-                                    <p:set>
-                                      <p:cBhvr>
-                                        <p:cTn id="50" dur="1" fill="hold">
-                                          <p:stCondLst>
-                                            <p:cond delay="0"/>
-                                          </p:stCondLst>
-                                        </p:cTn>
-                                        <p:tgtEl>
-                                          <p:spTgt spid="16"/>
-                                        </p:tgtEl>
-                                        <p:attrNameLst>
-                                          <p:attrName>style.visibility</p:attrName>
-                                        </p:attrNameLst>
-                                      </p:cBhvr>
-                                      <p:to>
-                                        <p:strVal val="visible"/>
-                                      </p:to>
-                                    </p:set>
-                                    <p:anim calcmode="lin" valueType="num">
-                                      <p:cBhvr additive="base">
-                                        <p:cTn id="51" dur="500" fill="hold"/>
-                                        <p:tgtEl>
-                                          <p:spTgt spid="16"/>
-                                        </p:tgtEl>
-                                        <p:attrNameLst>
-                                          <p:attrName>ppt_x</p:attrName>
-                                        </p:attrNameLst>
-                                      </p:cBhvr>
-                                      <p:tavLst>
-                                        <p:tav tm="0">
-                                          <p:val>
-                                            <p:strVal val="#ppt_x"/>
-                                          </p:val>
-                                        </p:tav>
-                                        <p:tav tm="100000">
-                                          <p:val>
-                                            <p:strVal val="#ppt_x"/>
-                                          </p:val>
-                                        </p:tav>
-                                      </p:tavLst>
-                                    </p:anim>
-                                    <p:anim calcmode="lin" valueType="num">
-                                      <p:cBhvr additive="base">
-                                        <p:cTn id="52" dur="500" fill="hold"/>
-                                        <p:tgtEl>
-                                          <p:spTgt spid="16"/>
-                                        </p:tgtEl>
-                                        <p:attrNameLst>
-                                          <p:attrName>ppt_y</p:attrName>
-                                        </p:attrNameLst>
-                                      </p:cBhvr>
-                                      <p:tavLst>
-                                        <p:tav tm="0">
-                                          <p:val>
-                                            <p:strVal val="1+#ppt_h/2"/>
-                                          </p:val>
-                                        </p:tav>
-                                        <p:tav tm="100000">
-                                          <p:val>
-                                            <p:strVal val="#ppt_y"/>
-                                          </p:val>
-                                        </p:tav>
-                                      </p:tavLst>
-                                    </p:anim>
+                                    <p:cmd type="call" cmd="playFrom(0.0)">
+                                      <p:cBhvr>
+                                        <p:cTn id="6" dur="7000" fill="hold"/>
+                                        <p:tgtEl>
+                                          <p:spTgt spid="26"/>
+                                        </p:tgtEl>
+                                      </p:cBhvr>
+                                    </p:cmd>
                                   </p:childTnLst>
                                 </p:cTn>
                               </p:par>
@@ -6082,20 +5334,22 @@
                 </p:cond>
               </p:nextCondLst>
             </p:seq>
+            <p:video>
+              <p:cMediaNode vol="80000">
+                <p:cTn id="7" display="0" fill="hold">
+                  <p:stCondLst>
+                    <p:cond delay="indefinite"/>
+                  </p:stCondLst>
+                </p:cTn>
+                <p:tgtEl>
+                  <p:spTgt spid="26"/>
+                </p:tgtEl>
+              </p:cMediaNode>
+            </p:video>
           </p:childTnLst>
         </p:cTn>
       </p:par>
     </p:tnLst>
-    <p:bldLst>
-      <p:bldP spid="5" grpId="0" animBg="1"/>
-      <p:bldP spid="7" grpId="0" animBg="1"/>
-      <p:bldP spid="8" grpId="0" animBg="1"/>
-      <p:bldP spid="10" grpId="0" animBg="1"/>
-      <p:bldP spid="11" grpId="0" animBg="1"/>
-      <p:bldP spid="13" grpId="0" animBg="1"/>
-      <p:bldP spid="14" grpId="0" animBg="1"/>
-      <p:bldP spid="16" grpId="0" animBg="1"/>
-    </p:bldLst>
   </p:timing>
 </p:sld>
 </file>
@@ -6119,13 +5373,49 @@
       </p:grpSpPr>
       <p:sp>
         <p:nvSpPr>
-          <p:cNvPr id="2" name="Video placeholder"/>
+          <p:cNvPr id="2" name="Clip label"/>
+          <p:cNvSpPr txBox="1"/>
+          <p:nvPr/>
+        </p:nvSpPr>
+        <p:spPr>
+          <a:xfrm>
+            <a:off x="822960" y="6446520"/>
+            <a:ext cx="6096000" cy="213360"/>
+          </a:xfrm>
+          <a:prstGeom prst="rect">
+            <a:avLst/>
+          </a:prstGeom>
+          <a:noFill/>
+          <a:ln/>
+        </p:spPr>
+        <p:txBody>
+          <a:bodyPr wrap="square" lIns="0" tIns="0" rIns="0" bIns="0" rtlCol="0" anchor="t"/>
+          <a:lstStyle/>
+          <a:p>
+            <a:pPr indent="0" marL="0">
+              <a:buNone/>
+            </a:pPr>
+            <a:r>
+              <a:rPr lang="en-US" sz="1000" b="1" dirty="0">
+                <a:solidFill>
+                  <a:srgbClr val="8FA0B5"/>
+                </a:solidFill>
+              </a:rPr>
+              <a:t>Video 2 · Clip 2</a:t>
+            </a:r>
+            <a:endParaRPr lang="en-US" sz="1000" dirty="0"/>
+          </a:p>
+        </p:txBody>
+      </p:sp>
+      <p:sp>
+        <p:nvSpPr>
+          <p:cNvPr id="3" name="Video placeholder"/>
           <p:cNvSpPr/>
           <p:nvPr/>
         </p:nvSpPr>
         <p:spPr>
           <a:xfrm>
-            <a:off x="822960" y="502920"/>
+            <a:off x="822960" y="381000"/>
             <a:ext cx="10546080" cy="5935980"/>
           </a:xfrm>
           <a:prstGeom prst="roundRect">
@@ -6146,13 +5436,13 @@
       </p:sp>
       <p:sp>
         <p:nvSpPr>
-          <p:cNvPr id="3" name="Play"/>
+          <p:cNvPr id="4" name="Play"/>
           <p:cNvSpPr/>
           <p:nvPr/>
         </p:nvSpPr>
         <p:spPr>
           <a:xfrm>
-            <a:off x="5638800" y="2362200"/>
+            <a:off x="5638800" y="2286000"/>
             <a:ext cx="914400" cy="914400"/>
           </a:xfrm>
           <a:prstGeom prst="ellipse">
@@ -6166,7 +5456,7 @@
       </p:sp>
       <p:pic>
         <p:nvPicPr>
-          <p:cNvPr id="4" name="Play icon" descr="preencoded.png">    </p:cNvPr>
+          <p:cNvPr id="5" name="Play icon" descr="preencoded.png">    </p:cNvPr>
           <p:cNvPicPr>
             <a:picLocks noChangeAspect="1"/>
           </p:cNvPicPr>
@@ -6180,7 +5470,7 @@
         </p:blipFill>
         <p:spPr>
           <a:xfrm>
-            <a:off x="5913120" y="2636520"/>
+            <a:off x="5913120" y="2560320"/>
             <a:ext cx="396240" cy="396240"/>
           </a:xfrm>
           <a:prstGeom prst="rect">
@@ -6190,13 +5480,13 @@
       </p:pic>
       <p:sp>
         <p:nvSpPr>
-          <p:cNvPr id="5" name="Video label"/>
+          <p:cNvPr id="6" name="Video title"/>
           <p:cNvSpPr txBox="1"/>
           <p:nvPr/>
         </p:nvSpPr>
         <p:spPr>
           <a:xfrm>
-            <a:off x="822960" y="3581400"/>
+            <a:off x="822960" y="3505200"/>
             <a:ext cx="10546080" cy="381000"/>
           </a:xfrm>
           <a:prstGeom prst="rect">
@@ -6218,7 +5508,7 @@
                   <a:schemeClr val="bg1"/>
                 </a:solidFill>
               </a:rPr>
-              <a:t>Demo video · about 1:20 · no audio</a:t>
+              <a:t>Video 2 · coming from Sebastien</a:t>
             </a:r>
             <a:endParaRPr lang="en-US" sz="1800" dirty="0"/>
           </a:p>
@@ -6226,13 +5516,13 @@
       </p:sp>
       <p:sp>
         <p:nvSpPr>
-          <p:cNvPr id="6" name="Video hint"/>
+          <p:cNvPr id="7" name="Video hint"/>
           <p:cNvSpPr txBox="1"/>
           <p:nvPr/>
         </p:nvSpPr>
         <p:spPr>
           <a:xfrm>
-            <a:off x="822960" y="4023360"/>
+            <a:off x="822960" y="3947160"/>
             <a:ext cx="10546080" cy="304800"/>
           </a:xfrm>
           <a:prstGeom prst="rect">
@@ -6335,6 +5625,510 @@
       </p:grpSpPr>
       <p:sp>
         <p:nvSpPr>
+          <p:cNvPr id="2" name="Clip label"/>
+          <p:cNvSpPr txBox="1"/>
+          <p:nvPr/>
+        </p:nvSpPr>
+        <p:spPr>
+          <a:xfrm>
+            <a:off x="822960" y="6446520"/>
+            <a:ext cx="6096000" cy="213360"/>
+          </a:xfrm>
+          <a:prstGeom prst="rect">
+            <a:avLst/>
+          </a:prstGeom>
+          <a:noFill/>
+          <a:ln/>
+        </p:spPr>
+        <p:txBody>
+          <a:bodyPr wrap="square" lIns="0" tIns="0" rIns="0" bIns="0" rtlCol="0" anchor="t"/>
+          <a:lstStyle/>
+          <a:p>
+            <a:pPr indent="0" marL="0">
+              <a:buNone/>
+            </a:pPr>
+            <a:r>
+              <a:rPr lang="en-US" sz="1000" b="1" dirty="0">
+                <a:solidFill>
+                  <a:srgbClr val="8FA0B5"/>
+                </a:solidFill>
+              </a:rPr>
+              <a:t>Video 3 · Clip 3</a:t>
+            </a:r>
+            <a:endParaRPr lang="en-US" sz="1000" dirty="0"/>
+          </a:p>
+        </p:txBody>
+      </p:sp>
+      <p:sp>
+        <p:nvSpPr>
+          <p:cNvPr id="3" name="Video placeholder"/>
+          <p:cNvSpPr/>
+          <p:nvPr/>
+        </p:nvSpPr>
+        <p:spPr>
+          <a:xfrm>
+            <a:off x="822960" y="381000"/>
+            <a:ext cx="10546080" cy="5935980"/>
+          </a:xfrm>
+          <a:prstGeom prst="roundRect">
+            <a:avLst>
+              <a:gd name="adj" fmla="val 3081"/>
+            </a:avLst>
+          </a:prstGeom>
+          <a:solidFill>
+            <a:schemeClr val="tx1"/>
+          </a:solidFill>
+          <a:ln w="12700">
+            <a:solidFill>
+              <a:srgbClr val="5F6F85"/>
+            </a:solidFill>
+            <a:prstDash val="dash"/>
+          </a:ln>
+        </p:spPr>
+      </p:sp>
+      <p:sp>
+        <p:nvSpPr>
+          <p:cNvPr id="4" name="Play"/>
+          <p:cNvSpPr/>
+          <p:nvPr/>
+        </p:nvSpPr>
+        <p:spPr>
+          <a:xfrm>
+            <a:off x="5638800" y="2286000"/>
+            <a:ext cx="914400" cy="914400"/>
+          </a:xfrm>
+          <a:prstGeom prst="ellipse">
+            <a:avLst/>
+          </a:prstGeom>
+          <a:solidFill>
+            <a:schemeClr val="accent1"/>
+          </a:solidFill>
+          <a:ln/>
+        </p:spPr>
+      </p:sp>
+      <p:pic>
+        <p:nvPicPr>
+          <p:cNvPr id="5" name="Play icon" descr="preencoded.png">    </p:cNvPr>
+          <p:cNvPicPr>
+            <a:picLocks noChangeAspect="1"/>
+          </p:cNvPicPr>
+          <p:nvPr/>
+        </p:nvPicPr>
+        <p:blipFill>
+          <a:blip r:embed="rId1"/>
+          <a:stretch>
+            <a:fillRect/>
+          </a:stretch>
+        </p:blipFill>
+        <p:spPr>
+          <a:xfrm>
+            <a:off x="5913120" y="2560320"/>
+            <a:ext cx="396240" cy="396240"/>
+          </a:xfrm>
+          <a:prstGeom prst="rect">
+            <a:avLst/>
+          </a:prstGeom>
+        </p:spPr>
+      </p:pic>
+      <p:sp>
+        <p:nvSpPr>
+          <p:cNvPr id="6" name="Video title"/>
+          <p:cNvSpPr txBox="1"/>
+          <p:nvPr/>
+        </p:nvSpPr>
+        <p:spPr>
+          <a:xfrm>
+            <a:off x="822960" y="3505200"/>
+            <a:ext cx="10546080" cy="381000"/>
+          </a:xfrm>
+          <a:prstGeom prst="rect">
+            <a:avLst/>
+          </a:prstGeom>
+          <a:noFill/>
+          <a:ln/>
+        </p:spPr>
+        <p:txBody>
+          <a:bodyPr wrap="square" lIns="0" tIns="0" rIns="0" bIns="0" rtlCol="0" anchor="t"/>
+          <a:lstStyle/>
+          <a:p>
+            <a:pPr algn="ctr" indent="0" marL="0">
+              <a:buNone/>
+            </a:pPr>
+            <a:r>
+              <a:rPr lang="en-US" sz="1800" b="1" dirty="0">
+                <a:solidFill>
+                  <a:schemeClr val="bg1"/>
+                </a:solidFill>
+              </a:rPr>
+              <a:t>Video 3 · coming from Sebastien</a:t>
+            </a:r>
+            <a:endParaRPr lang="en-US" sz="1800" dirty="0"/>
+          </a:p>
+        </p:txBody>
+      </p:sp>
+      <p:sp>
+        <p:nvSpPr>
+          <p:cNvPr id="7" name="Video hint"/>
+          <p:cNvSpPr txBox="1"/>
+          <p:nvPr/>
+        </p:nvSpPr>
+        <p:spPr>
+          <a:xfrm>
+            <a:off x="822960" y="3947160"/>
+            <a:ext cx="10546080" cy="304800"/>
+          </a:xfrm>
+          <a:prstGeom prst="rect">
+            <a:avLst/>
+          </a:prstGeom>
+          <a:noFill/>
+          <a:ln/>
+        </p:spPr>
+        <p:txBody>
+          <a:bodyPr wrap="square" lIns="0" tIns="0" rIns="0" bIns="0" rtlCol="0" anchor="t"/>
+          <a:lstStyle/>
+          <a:p>
+            <a:pPr algn="ctr" indent="0" marL="0">
+              <a:buNone/>
+            </a:pPr>
+            <a:r>
+              <a:rPr lang="en-US" sz="1140" dirty="0">
+                <a:solidFill>
+                  <a:schemeClr val="bg2"/>
+                </a:solidFill>
+              </a:rPr>
+              <a:t>Replace this box: Insert › Video › This Device, then Playback › Start: Automatically</a:t>
+            </a:r>
+            <a:endParaRPr lang="en-US" sz="1140" dirty="0"/>
+          </a:p>
+        </p:txBody>
+      </p:sp>
+      <p:sp>
+        <p:nvSpPr>
+          <p:cNvPr id="25" name="Slide Number Placeholder 0"/>
+          <p:cNvSpPr>
+            <a:spLocks noGrp="1"/>
+          </p:cNvSpPr>
+          <p:nvPr>
+            <p:ph type="sldNum" sz="quarter" idx="4294967295"/>
+          </p:nvPr>
+        </p:nvSpPr>
+        <p:spPr>
+          <a:xfrm>
+            <a:off x="11338560" y="6355080"/>
+            <a:ext cx="457200" cy="274320"/>
+          </a:xfrm>
+          <a:prstGeom prst="rect">
+            <a:avLst/>
+          </a:prstGeom>
+          <a:extLst>
+            <a:ext uri="{C572A759-6A51-4108-AA02-DFA0A04FC94B}">
+              <ma14:wrappingTextBoxFlag xmlns:ma14="http://schemas.microsoft.com/office/mac/drawingml/2011/main" val="0"/>
+            </a:ext>
+          </a:extLst>
+        </p:spPr>
+        <p:txBody>
+          <a:bodyPr/>
+          <a:lstStyle>
+            <a:lvl1pPr>
+              <a:defRPr sz="900">
+                <a:solidFill>
+                  <a:schemeClr val="accent6"/>
+                </a:solidFill>
+              </a:defRPr>
+            </a:lvl1pPr>
+          </a:lstStyle>
+          <a:p>
+            <a:pPr algn="r"/>
+            <a:fld id="{F7021451-1387-4CA6-816F-3879F97B5CBC}" type="slidenum">
+              <a:rPr b="0" lang="en-US"/>
+              <a:t>6</a:t>
+            </a:fld>
+            <a:endParaRPr lang="en-US"/>
+          </a:p>
+        </p:txBody>
+      </p:sp>
+    </p:spTree>
+  </p:cSld>
+  <p:clrMapOvr>
+    <a:masterClrMapping/>
+  </p:clrMapOvr>
+  <p:transition spd="med">
+    <p:fade/>
+  </p:transition>
+</p:sld>
+</file>
+
+<file path=ppt/slides/slide7.xml><?xml version="1.0" encoding="utf-8"?>
+<p:sld xmlns:a="http://schemas.openxmlformats.org/drawingml/2006/main" xmlns:r="http://schemas.openxmlformats.org/officeDocument/2006/relationships" xmlns:p="http://schemas.openxmlformats.org/presentationml/2006/main">
+  <p:cSld name="Slide 7">
+    <p:spTree>
+      <p:nvGrpSpPr>
+        <p:cNvPr id="1" name=""/>
+        <p:cNvGrpSpPr/>
+        <p:nvPr/>
+      </p:nvGrpSpPr>
+      <p:grpSpPr>
+        <a:xfrm>
+          <a:off x="0" y="0"/>
+          <a:ext cx="0" cy="0"/>
+          <a:chOff x="0" y="0"/>
+          <a:chExt cx="0" cy="0"/>
+        </a:xfrm>
+      </p:grpSpPr>
+      <p:sp>
+        <p:nvSpPr>
+          <p:cNvPr id="2" name="Clip label"/>
+          <p:cNvSpPr txBox="1"/>
+          <p:nvPr/>
+        </p:nvSpPr>
+        <p:spPr>
+          <a:xfrm>
+            <a:off x="822960" y="6446520"/>
+            <a:ext cx="6096000" cy="213360"/>
+          </a:xfrm>
+          <a:prstGeom prst="rect">
+            <a:avLst/>
+          </a:prstGeom>
+          <a:noFill/>
+          <a:ln/>
+        </p:spPr>
+        <p:txBody>
+          <a:bodyPr wrap="square" lIns="0" tIns="0" rIns="0" bIns="0" rtlCol="0" anchor="t"/>
+          <a:lstStyle/>
+          <a:p>
+            <a:pPr indent="0" marL="0">
+              <a:buNone/>
+            </a:pPr>
+            <a:r>
+              <a:rPr lang="en-US" sz="1000" b="1" dirty="0">
+                <a:solidFill>
+                  <a:srgbClr val="8FA0B5"/>
+                </a:solidFill>
+              </a:rPr>
+              <a:t>Video 4 · Clip 4</a:t>
+            </a:r>
+            <a:endParaRPr lang="en-US" sz="1000" dirty="0"/>
+          </a:p>
+        </p:txBody>
+      </p:sp>
+      <p:sp>
+        <p:nvSpPr>
+          <p:cNvPr id="3" name="Video placeholder"/>
+          <p:cNvSpPr/>
+          <p:nvPr/>
+        </p:nvSpPr>
+        <p:spPr>
+          <a:xfrm>
+            <a:off x="822960" y="381000"/>
+            <a:ext cx="10546080" cy="5935980"/>
+          </a:xfrm>
+          <a:prstGeom prst="roundRect">
+            <a:avLst>
+              <a:gd name="adj" fmla="val 3081"/>
+            </a:avLst>
+          </a:prstGeom>
+          <a:solidFill>
+            <a:schemeClr val="tx1"/>
+          </a:solidFill>
+          <a:ln w="12700">
+            <a:solidFill>
+              <a:srgbClr val="5F6F85"/>
+            </a:solidFill>
+            <a:prstDash val="dash"/>
+          </a:ln>
+        </p:spPr>
+      </p:sp>
+      <p:sp>
+        <p:nvSpPr>
+          <p:cNvPr id="4" name="Play"/>
+          <p:cNvSpPr/>
+          <p:nvPr/>
+        </p:nvSpPr>
+        <p:spPr>
+          <a:xfrm>
+            <a:off x="5638800" y="2286000"/>
+            <a:ext cx="914400" cy="914400"/>
+          </a:xfrm>
+          <a:prstGeom prst="ellipse">
+            <a:avLst/>
+          </a:prstGeom>
+          <a:solidFill>
+            <a:schemeClr val="accent1"/>
+          </a:solidFill>
+          <a:ln/>
+        </p:spPr>
+      </p:sp>
+      <p:pic>
+        <p:nvPicPr>
+          <p:cNvPr id="5" name="Play icon" descr="preencoded.png">    </p:cNvPr>
+          <p:cNvPicPr>
+            <a:picLocks noChangeAspect="1"/>
+          </p:cNvPicPr>
+          <p:nvPr/>
+        </p:nvPicPr>
+        <p:blipFill>
+          <a:blip r:embed="rId1"/>
+          <a:stretch>
+            <a:fillRect/>
+          </a:stretch>
+        </p:blipFill>
+        <p:spPr>
+          <a:xfrm>
+            <a:off x="5913120" y="2560320"/>
+            <a:ext cx="396240" cy="396240"/>
+          </a:xfrm>
+          <a:prstGeom prst="rect">
+            <a:avLst/>
+          </a:prstGeom>
+        </p:spPr>
+      </p:pic>
+      <p:sp>
+        <p:nvSpPr>
+          <p:cNvPr id="6" name="Video title"/>
+          <p:cNvSpPr txBox="1"/>
+          <p:nvPr/>
+        </p:nvSpPr>
+        <p:spPr>
+          <a:xfrm>
+            <a:off x="822960" y="3505200"/>
+            <a:ext cx="10546080" cy="381000"/>
+          </a:xfrm>
+          <a:prstGeom prst="rect">
+            <a:avLst/>
+          </a:prstGeom>
+          <a:noFill/>
+          <a:ln/>
+        </p:spPr>
+        <p:txBody>
+          <a:bodyPr wrap="square" lIns="0" tIns="0" rIns="0" bIns="0" rtlCol="0" anchor="t"/>
+          <a:lstStyle/>
+          <a:p>
+            <a:pPr algn="ctr" indent="0" marL="0">
+              <a:buNone/>
+            </a:pPr>
+            <a:r>
+              <a:rPr lang="en-US" sz="1800" b="1" dirty="0">
+                <a:solidFill>
+                  <a:schemeClr val="bg1"/>
+                </a:solidFill>
+              </a:rPr>
+              <a:t>Video 4 · coming from Sebastien</a:t>
+            </a:r>
+            <a:endParaRPr lang="en-US" sz="1800" dirty="0"/>
+          </a:p>
+        </p:txBody>
+      </p:sp>
+      <p:sp>
+        <p:nvSpPr>
+          <p:cNvPr id="7" name="Video hint"/>
+          <p:cNvSpPr txBox="1"/>
+          <p:nvPr/>
+        </p:nvSpPr>
+        <p:spPr>
+          <a:xfrm>
+            <a:off x="822960" y="3947160"/>
+            <a:ext cx="10546080" cy="304800"/>
+          </a:xfrm>
+          <a:prstGeom prst="rect">
+            <a:avLst/>
+          </a:prstGeom>
+          <a:noFill/>
+          <a:ln/>
+        </p:spPr>
+        <p:txBody>
+          <a:bodyPr wrap="square" lIns="0" tIns="0" rIns="0" bIns="0" rtlCol="0" anchor="t"/>
+          <a:lstStyle/>
+          <a:p>
+            <a:pPr algn="ctr" indent="0" marL="0">
+              <a:buNone/>
+            </a:pPr>
+            <a:r>
+              <a:rPr lang="en-US" sz="1140" dirty="0">
+                <a:solidFill>
+                  <a:schemeClr val="bg2"/>
+                </a:solidFill>
+              </a:rPr>
+              <a:t>Replace this box: Insert › Video › This Device, then Playback › Start: Automatically</a:t>
+            </a:r>
+            <a:endParaRPr lang="en-US" sz="1140" dirty="0"/>
+          </a:p>
+        </p:txBody>
+      </p:sp>
+      <p:sp>
+        <p:nvSpPr>
+          <p:cNvPr id="25" name="Slide Number Placeholder 0"/>
+          <p:cNvSpPr>
+            <a:spLocks noGrp="1"/>
+          </p:cNvSpPr>
+          <p:nvPr>
+            <p:ph type="sldNum" sz="quarter" idx="4294967295"/>
+          </p:nvPr>
+        </p:nvSpPr>
+        <p:spPr>
+          <a:xfrm>
+            <a:off x="11338560" y="6355080"/>
+            <a:ext cx="457200" cy="274320"/>
+          </a:xfrm>
+          <a:prstGeom prst="rect">
+            <a:avLst/>
+          </a:prstGeom>
+          <a:extLst>
+            <a:ext uri="{C572A759-6A51-4108-AA02-DFA0A04FC94B}">
+              <ma14:wrappingTextBoxFlag xmlns:ma14="http://schemas.microsoft.com/office/mac/drawingml/2011/main" val="0"/>
+            </a:ext>
+          </a:extLst>
+        </p:spPr>
+        <p:txBody>
+          <a:bodyPr/>
+          <a:lstStyle>
+            <a:lvl1pPr>
+              <a:defRPr sz="900">
+                <a:solidFill>
+                  <a:schemeClr val="accent6"/>
+                </a:solidFill>
+              </a:defRPr>
+            </a:lvl1pPr>
+          </a:lstStyle>
+          <a:p>
+            <a:pPr algn="r"/>
+            <a:fld id="{F7021451-1387-4CA6-816F-3879F97B5CBC}" type="slidenum">
+              <a:rPr b="0" lang="en-US"/>
+              <a:t>7</a:t>
+            </a:fld>
+            <a:endParaRPr lang="en-US"/>
+          </a:p>
+        </p:txBody>
+      </p:sp>
+    </p:spTree>
+  </p:cSld>
+  <p:clrMapOvr>
+    <a:masterClrMapping/>
+  </p:clrMapOvr>
+  <p:transition spd="med">
+    <p:fade/>
+  </p:transition>
+</p:sld>
+</file>
+
+<file path=ppt/slides/slide8.xml><?xml version="1.0" encoding="utf-8"?>
+<p:sld xmlns:a="http://schemas.openxmlformats.org/drawingml/2006/main" xmlns:r="http://schemas.openxmlformats.org/officeDocument/2006/relationships" xmlns:p="http://schemas.openxmlformats.org/presentationml/2006/main">
+  <p:cSld name="Slide 8">
+    <p:spTree>
+      <p:nvGrpSpPr>
+        <p:cNvPr id="1" name=""/>
+        <p:cNvGrpSpPr/>
+        <p:nvPr/>
+      </p:nvGrpSpPr>
+      <p:grpSpPr>
+        <a:xfrm>
+          <a:off x="0" y="0"/>
+          <a:ext cx="0" cy="0"/>
+          <a:chOff x="0" y="0"/>
+          <a:chExt cx="0" cy="0"/>
+        </a:xfrm>
+      </p:grpSpPr>
+      <p:sp>
+        <p:nvSpPr>
           <p:cNvPr id="2" name="Title"/>
           <p:cNvSpPr txBox="1"/>
           <p:nvPr/>
@@ -7560,7 +7354,7 @@
             <a:pPr algn="r"/>
             <a:fld id="{F7021451-1387-4CA6-816F-3879F97B5CBC}" type="slidenum">
               <a:rPr b="0" lang="en-US"/>
-              <a:t>6</a:t>
+              <a:t>8</a:t>
             </a:fld>
             <a:endParaRPr lang="en-US"/>
           </a:p>
@@ -8551,9 +8345,9 @@
 </p:sld>
 </file>
 
-<file path=ppt/slides/slide7.xml><?xml version="1.0" encoding="utf-8"?>
+<file path=ppt/slides/slide9.xml><?xml version="1.0" encoding="utf-8"?>
 <p:sld xmlns:a="http://schemas.openxmlformats.org/drawingml/2006/main" xmlns:r="http://schemas.openxmlformats.org/officeDocument/2006/relationships" xmlns:p="http://schemas.openxmlformats.org/presentationml/2006/main">
-  <p:cSld name="Slide 7">
+  <p:cSld name="Slide 9">
     <p:spTree>
       <p:nvGrpSpPr>
         <p:cNvPr id="1" name=""/>
@@ -8837,7 +8631,7 @@
             <a:pPr algn="r"/>
             <a:fld id="{F7021451-1387-4CA6-816F-3879F97B5CBC}" type="slidenum">
               <a:rPr b="0" lang="en-US"/>
-              <a:t>7</a:t>
+              <a:t>9</a:t>
             </a:fld>
             <a:endParaRPr lang="en-US"/>
           </a:p>
@@ -9012,687 +8806,6 @@
       <p:bldP spid="6" grpId="0" animBg="1"/>
     </p:bldLst>
   </p:timing>
-</p:sld>
-</file>
-
-<file path=ppt/slides/slide8.xml><?xml version="1.0" encoding="utf-8"?>
-<p:sld xmlns:a="http://schemas.openxmlformats.org/drawingml/2006/main" xmlns:r="http://schemas.openxmlformats.org/officeDocument/2006/relationships" xmlns:p="http://schemas.openxmlformats.org/presentationml/2006/main">
-  <p:cSld name="Slide 8">
-    <p:spTree>
-      <p:nvGrpSpPr>
-        <p:cNvPr id="1" name=""/>
-        <p:cNvGrpSpPr/>
-        <p:nvPr/>
-      </p:nvGrpSpPr>
-      <p:grpSpPr>
-        <a:xfrm>
-          <a:off x="0" y="0"/>
-          <a:ext cx="0" cy="0"/>
-          <a:chOff x="0" y="0"/>
-          <a:chExt cx="0" cy="0"/>
-        </a:xfrm>
-      </p:grpSpPr>
-      <p:sp>
-        <p:nvSpPr>
-          <p:cNvPr id="2" name="Title"/>
-          <p:cNvSpPr txBox="1"/>
-          <p:nvPr/>
-        </p:nvSpPr>
-        <p:spPr>
-          <a:xfrm>
-            <a:off x="548640" y="457200"/>
-            <a:ext cx="10668000" cy="609600"/>
-          </a:xfrm>
-          <a:prstGeom prst="rect">
-            <a:avLst/>
-          </a:prstGeom>
-          <a:noFill/>
-          <a:ln/>
-        </p:spPr>
-        <p:txBody>
-          <a:bodyPr wrap="square" lIns="0" tIns="0" rIns="0" bIns="0" rtlCol="0" anchor="t"/>
-          <a:lstStyle/>
-          <a:p>
-            <a:pPr indent="0" marL="0">
-              <a:buNone/>
-            </a:pPr>
-            <a:r>
-              <a:rPr lang="en-US" sz="3240" b="1" dirty="0">
-                <a:solidFill>
-                  <a:schemeClr val="tx1"/>
-                </a:solidFill>
-              </a:rPr>
-              <a:t>How Finn decides what to trust</a:t>
-            </a:r>
-            <a:endParaRPr lang="en-US" sz="3240" dirty="0"/>
-          </a:p>
-        </p:txBody>
-      </p:sp>
-      <p:sp>
-        <p:nvSpPr>
-          <p:cNvPr id="3" name="Sub"/>
-          <p:cNvSpPr txBox="1"/>
-          <p:nvPr/>
-        </p:nvSpPr>
-        <p:spPr>
-          <a:xfrm>
-            <a:off x="548640" y="1234440"/>
-            <a:ext cx="9144000" cy="304800"/>
-          </a:xfrm>
-          <a:prstGeom prst="rect">
-            <a:avLst/>
-          </a:prstGeom>
-          <a:noFill/>
-          <a:ln/>
-        </p:spPr>
-        <p:txBody>
-          <a:bodyPr wrap="square" lIns="0" tIns="0" rIns="0" bIns="0" rtlCol="0" anchor="t"/>
-          <a:lstStyle/>
-          <a:p>
-            <a:pPr indent="0" marL="0">
-              <a:buNone/>
-            </a:pPr>
-            <a:r>
-              <a:rPr lang="en-US" sz="1320" dirty="0">
-                <a:solidFill>
-                  <a:schemeClr val="accent6"/>
-                </a:solidFill>
-              </a:rPr>
-              <a:t>Every percentage on screen comes with its reasons</a:t>
-            </a:r>
-            <a:endParaRPr lang="en-US" sz="1320" dirty="0"/>
-          </a:p>
-        </p:txBody>
-      </p:sp>
-      <p:sp>
-        <p:nvSpPr>
-          <p:cNvPr id="4" name="Factor Authority"/>
-          <p:cNvSpPr/>
-          <p:nvPr/>
-        </p:nvSpPr>
-        <p:spPr>
-          <a:xfrm>
-            <a:off x="548640" y="2011680"/>
-            <a:ext cx="5440680" cy="1737360"/>
-          </a:xfrm>
-          <a:prstGeom prst="roundRect">
-            <a:avLst>
-              <a:gd name="adj" fmla="val 7895"/>
-            </a:avLst>
-          </a:prstGeom>
-          <a:solidFill>
-            <a:schemeClr val="bg1"/>
-          </a:solidFill>
-          <a:ln w="12700">
-            <a:solidFill>
-              <a:srgbClr val="E5E1D8"/>
-            </a:solidFill>
-            <a:prstDash val="solid"/>
-          </a:ln>
-          <a:effectLst>
-            <a:outerShdw sx="100000" sy="100000" kx="0" ky="0" algn="bl" rotWithShape="0" blurRad="152400" dist="50800" dir="5400000">
-              <a:srgbClr val="192D46">
-                <a:alpha val="12000"/>
-              </a:srgbClr>
-            </a:outerShdw>
-          </a:effectLst>
-        </p:spPr>
-      </p:sp>
-      <p:sp>
-        <p:nvSpPr>
-          <p:cNvPr id="5" name="Factor dot Authority"/>
-          <p:cNvSpPr/>
-          <p:nvPr/>
-        </p:nvSpPr>
-        <p:spPr>
-          <a:xfrm>
-            <a:off x="868680" y="2377440"/>
-            <a:ext cx="822960" cy="822960"/>
-          </a:xfrm>
-          <a:prstGeom prst="ellipse">
-            <a:avLst/>
-          </a:prstGeom>
-          <a:solidFill>
-            <a:schemeClr val="bg2"/>
-          </a:solidFill>
-          <a:ln/>
-        </p:spPr>
-      </p:sp>
-      <p:pic>
-        <p:nvPicPr>
-          <p:cNvPr id="6" name="Factor icon Authority" descr="preencoded.png">    </p:cNvPr>
-          <p:cNvPicPr>
-            <a:picLocks noChangeAspect="1"/>
-          </p:cNvPicPr>
-          <p:nvPr/>
-        </p:nvPicPr>
-        <p:blipFill>
-          <a:blip r:embed="rId1"/>
-          <a:stretch>
-            <a:fillRect/>
-          </a:stretch>
-        </p:blipFill>
-        <p:spPr>
-          <a:xfrm>
-            <a:off x="1082040" y="2590800"/>
-            <a:ext cx="396240" cy="396240"/>
-          </a:xfrm>
-          <a:prstGeom prst="rect">
-            <a:avLst/>
-          </a:prstGeom>
-        </p:spPr>
-      </p:pic>
-      <p:sp>
-        <p:nvSpPr>
-          <p:cNvPr id="7" name="Factor text Authority"/>
-          <p:cNvSpPr txBox="1"/>
-          <p:nvPr/>
-        </p:nvSpPr>
-        <p:spPr>
-          <a:xfrm>
-            <a:off x="1965960" y="2331720"/>
-            <a:ext cx="3810000" cy="1219200"/>
-          </a:xfrm>
-          <a:prstGeom prst="rect">
-            <a:avLst/>
-          </a:prstGeom>
-          <a:noFill/>
-          <a:ln/>
-        </p:spPr>
-        <p:txBody>
-          <a:bodyPr wrap="square" lIns="0" tIns="0" rIns="0" bIns="0" rtlCol="0" anchor="t"/>
-          <a:lstStyle/>
-          <a:p>
-            <a:pPr indent="0" marL="0">
-              <a:spcAft>
-                <a:spcPts val="600"/>
-              </a:spcAft>
-              <a:buNone/>
-            </a:pPr>
-            <a:r>
-              <a:rPr lang="en-US" sz="1800" b="1" dirty="0">
-                <a:solidFill>
-                  <a:schemeClr val="tx1"/>
-                </a:solidFill>
-              </a:rPr>
-              <a:t>Authority</a:t>
-            </a:r>
-            <a:endParaRPr lang="en-US" sz="1800" dirty="0"/>
-          </a:p>
-          <a:p>
-            <a:pPr indent="0" marL="0">
-              <a:spcAft>
-                <a:spcPts val="600"/>
-              </a:spcAft>
-              <a:buNone/>
-            </a:pPr>
-            <a:r>
-              <a:rPr lang="en-US" sz="1260" dirty="0">
-                <a:solidFill>
-                  <a:schemeClr val="accent6"/>
-                </a:solidFill>
-              </a:rPr>
-              <a:t>Approved by the owner beats a chat message or a meeting proposal</a:t>
-            </a:r>
-            <a:endParaRPr lang="en-US" sz="1800" dirty="0"/>
-          </a:p>
-        </p:txBody>
-      </p:sp>
-      <p:sp>
-        <p:nvSpPr>
-          <p:cNvPr id="8" name="Factor Scope"/>
-          <p:cNvSpPr/>
-          <p:nvPr/>
-        </p:nvSpPr>
-        <p:spPr>
-          <a:xfrm>
-            <a:off x="6172200" y="2011680"/>
-            <a:ext cx="5440680" cy="1737360"/>
-          </a:xfrm>
-          <a:prstGeom prst="roundRect">
-            <a:avLst>
-              <a:gd name="adj" fmla="val 7895"/>
-            </a:avLst>
-          </a:prstGeom>
-          <a:solidFill>
-            <a:schemeClr val="bg1"/>
-          </a:solidFill>
-          <a:ln w="12700">
-            <a:solidFill>
-              <a:srgbClr val="E5E1D8"/>
-            </a:solidFill>
-            <a:prstDash val="solid"/>
-          </a:ln>
-          <a:effectLst>
-            <a:outerShdw sx="100000" sy="100000" kx="0" ky="0" algn="bl" rotWithShape="0" blurRad="152400" dist="50800" dir="5400000">
-              <a:srgbClr val="192D46">
-                <a:alpha val="12000"/>
-              </a:srgbClr>
-            </a:outerShdw>
-          </a:effectLst>
-        </p:spPr>
-      </p:sp>
-      <p:sp>
-        <p:nvSpPr>
-          <p:cNvPr id="9" name="Factor dot Scope"/>
-          <p:cNvSpPr/>
-          <p:nvPr/>
-        </p:nvSpPr>
-        <p:spPr>
-          <a:xfrm>
-            <a:off x="6492240" y="2377440"/>
-            <a:ext cx="822960" cy="822960"/>
-          </a:xfrm>
-          <a:prstGeom prst="ellipse">
-            <a:avLst/>
-          </a:prstGeom>
-          <a:solidFill>
-            <a:schemeClr val="bg2"/>
-          </a:solidFill>
-          <a:ln/>
-        </p:spPr>
-      </p:sp>
-      <p:pic>
-        <p:nvPicPr>
-          <p:cNvPr id="10" name="Factor icon Scope" descr="preencoded.png">    </p:cNvPr>
-          <p:cNvPicPr>
-            <a:picLocks noChangeAspect="1"/>
-          </p:cNvPicPr>
-          <p:nvPr/>
-        </p:nvPicPr>
-        <p:blipFill>
-          <a:blip r:embed="rId2"/>
-          <a:stretch>
-            <a:fillRect/>
-          </a:stretch>
-        </p:blipFill>
-        <p:spPr>
-          <a:xfrm>
-            <a:off x="6705600" y="2590800"/>
-            <a:ext cx="396240" cy="396240"/>
-          </a:xfrm>
-          <a:prstGeom prst="rect">
-            <a:avLst/>
-          </a:prstGeom>
-        </p:spPr>
-      </p:pic>
-      <p:sp>
-        <p:nvSpPr>
-          <p:cNvPr id="11" name="Factor text Scope"/>
-          <p:cNvSpPr txBox="1"/>
-          <p:nvPr/>
-        </p:nvSpPr>
-        <p:spPr>
-          <a:xfrm>
-            <a:off x="7589520" y="2331720"/>
-            <a:ext cx="3810000" cy="1219200"/>
-          </a:xfrm>
-          <a:prstGeom prst="rect">
-            <a:avLst/>
-          </a:prstGeom>
-          <a:noFill/>
-          <a:ln/>
-        </p:spPr>
-        <p:txBody>
-          <a:bodyPr wrap="square" lIns="0" tIns="0" rIns="0" bIns="0" rtlCol="0" anchor="t"/>
-          <a:lstStyle/>
-          <a:p>
-            <a:pPr indent="0" marL="0">
-              <a:spcAft>
-                <a:spcPts val="600"/>
-              </a:spcAft>
-              <a:buNone/>
-            </a:pPr>
-            <a:r>
-              <a:rPr lang="en-US" sz="1800" b="1" dirty="0">
-                <a:solidFill>
-                  <a:schemeClr val="tx1"/>
-                </a:solidFill>
-              </a:rPr>
-              <a:t>Scope</a:t>
-            </a:r>
-            <a:endParaRPr lang="en-US" sz="1800" dirty="0"/>
-          </a:p>
-          <a:p>
-            <a:pPr indent="0" marL="0">
-              <a:spcAft>
-                <a:spcPts val="600"/>
-              </a:spcAft>
-              <a:buNone/>
-            </a:pPr>
-            <a:r>
-              <a:rPr lang="en-US" sz="1260" dirty="0">
-                <a:solidFill>
-                  <a:schemeClr val="accent6"/>
-                </a:solidFill>
-              </a:rPr>
-              <a:t>Valid for this country, this client and this period</a:t>
-            </a:r>
-            <a:endParaRPr lang="en-US" sz="1800" dirty="0"/>
-          </a:p>
-        </p:txBody>
-      </p:sp>
-      <p:sp>
-        <p:nvSpPr>
-          <p:cNvPr id="12" name="Factor Validity"/>
-          <p:cNvSpPr/>
-          <p:nvPr/>
-        </p:nvSpPr>
-        <p:spPr>
-          <a:xfrm>
-            <a:off x="548640" y="3977640"/>
-            <a:ext cx="5440680" cy="1737360"/>
-          </a:xfrm>
-          <a:prstGeom prst="roundRect">
-            <a:avLst>
-              <a:gd name="adj" fmla="val 7895"/>
-            </a:avLst>
-          </a:prstGeom>
-          <a:solidFill>
-            <a:schemeClr val="bg1"/>
-          </a:solidFill>
-          <a:ln w="12700">
-            <a:solidFill>
-              <a:srgbClr val="E5E1D8"/>
-            </a:solidFill>
-            <a:prstDash val="solid"/>
-          </a:ln>
-          <a:effectLst>
-            <a:outerShdw sx="100000" sy="100000" kx="0" ky="0" algn="bl" rotWithShape="0" blurRad="152400" dist="50800" dir="5400000">
-              <a:srgbClr val="192D46">
-                <a:alpha val="12000"/>
-              </a:srgbClr>
-            </a:outerShdw>
-          </a:effectLst>
-        </p:spPr>
-      </p:sp>
-      <p:sp>
-        <p:nvSpPr>
-          <p:cNvPr id="13" name="Factor dot Validity"/>
-          <p:cNvSpPr/>
-          <p:nvPr/>
-        </p:nvSpPr>
-        <p:spPr>
-          <a:xfrm>
-            <a:off x="868680" y="4343400"/>
-            <a:ext cx="822960" cy="822960"/>
-          </a:xfrm>
-          <a:prstGeom prst="ellipse">
-            <a:avLst/>
-          </a:prstGeom>
-          <a:solidFill>
-            <a:schemeClr val="bg2"/>
-          </a:solidFill>
-          <a:ln/>
-        </p:spPr>
-      </p:sp>
-      <p:pic>
-        <p:nvPicPr>
-          <p:cNvPr id="14" name="Factor icon Validity" descr="preencoded.png">    </p:cNvPr>
-          <p:cNvPicPr>
-            <a:picLocks noChangeAspect="1"/>
-          </p:cNvPicPr>
-          <p:nvPr/>
-        </p:nvPicPr>
-        <p:blipFill>
-          <a:blip r:embed="rId3"/>
-          <a:stretch>
-            <a:fillRect/>
-          </a:stretch>
-        </p:blipFill>
-        <p:spPr>
-          <a:xfrm>
-            <a:off x="1082040" y="4556760"/>
-            <a:ext cx="396240" cy="396240"/>
-          </a:xfrm>
-          <a:prstGeom prst="rect">
-            <a:avLst/>
-          </a:prstGeom>
-        </p:spPr>
-      </p:pic>
-      <p:sp>
-        <p:nvSpPr>
-          <p:cNvPr id="15" name="Factor text Validity"/>
-          <p:cNvSpPr txBox="1"/>
-          <p:nvPr/>
-        </p:nvSpPr>
-        <p:spPr>
-          <a:xfrm>
-            <a:off x="1965960" y="4297680"/>
-            <a:ext cx="3810000" cy="1219200"/>
-          </a:xfrm>
-          <a:prstGeom prst="rect">
-            <a:avLst/>
-          </a:prstGeom>
-          <a:noFill/>
-          <a:ln/>
-        </p:spPr>
-        <p:txBody>
-          <a:bodyPr wrap="square" lIns="0" tIns="0" rIns="0" bIns="0" rtlCol="0" anchor="t"/>
-          <a:lstStyle/>
-          <a:p>
-            <a:pPr indent="0" marL="0">
-              <a:spcAft>
-                <a:spcPts val="600"/>
-              </a:spcAft>
-              <a:buNone/>
-            </a:pPr>
-            <a:r>
-              <a:rPr lang="en-US" sz="1800" b="1" dirty="0">
-                <a:solidFill>
-                  <a:schemeClr val="tx1"/>
-                </a:solidFill>
-              </a:rPr>
-              <a:t>Validity</a:t>
-            </a:r>
-            <a:endParaRPr lang="en-US" sz="1800" dirty="0"/>
-          </a:p>
-          <a:p>
-            <a:pPr indent="0" marL="0">
-              <a:spcAft>
-                <a:spcPts val="600"/>
-              </a:spcAft>
-              <a:buNone/>
-            </a:pPr>
-            <a:r>
-              <a:rPr lang="en-US" sz="1260" dirty="0">
-                <a:solidFill>
-                  <a:schemeClr val="accent6"/>
-                </a:solidFill>
-              </a:rPr>
-              <a:t>Superseded or expired versions lose, even if they look official</a:t>
-            </a:r>
-            <a:endParaRPr lang="en-US" sz="1800" dirty="0"/>
-          </a:p>
-        </p:txBody>
-      </p:sp>
-      <p:sp>
-        <p:nvSpPr>
-          <p:cNvPr id="16" name="Factor Agreement"/>
-          <p:cNvSpPr/>
-          <p:nvPr/>
-        </p:nvSpPr>
-        <p:spPr>
-          <a:xfrm>
-            <a:off x="6172200" y="3977640"/>
-            <a:ext cx="5440680" cy="1737360"/>
-          </a:xfrm>
-          <a:prstGeom prst="roundRect">
-            <a:avLst>
-              <a:gd name="adj" fmla="val 7895"/>
-            </a:avLst>
-          </a:prstGeom>
-          <a:solidFill>
-            <a:schemeClr val="bg1"/>
-          </a:solidFill>
-          <a:ln w="12700">
-            <a:solidFill>
-              <a:srgbClr val="E5E1D8"/>
-            </a:solidFill>
-            <a:prstDash val="solid"/>
-          </a:ln>
-          <a:effectLst>
-            <a:outerShdw sx="100000" sy="100000" kx="0" ky="0" algn="bl" rotWithShape="0" blurRad="152400" dist="50800" dir="5400000">
-              <a:srgbClr val="192D46">
-                <a:alpha val="12000"/>
-              </a:srgbClr>
-            </a:outerShdw>
-          </a:effectLst>
-        </p:spPr>
-      </p:sp>
-      <p:sp>
-        <p:nvSpPr>
-          <p:cNvPr id="17" name="Factor dot Agreement"/>
-          <p:cNvSpPr/>
-          <p:nvPr/>
-        </p:nvSpPr>
-        <p:spPr>
-          <a:xfrm>
-            <a:off x="6492240" y="4343400"/>
-            <a:ext cx="822960" cy="822960"/>
-          </a:xfrm>
-          <a:prstGeom prst="ellipse">
-            <a:avLst/>
-          </a:prstGeom>
-          <a:solidFill>
-            <a:schemeClr val="bg2"/>
-          </a:solidFill>
-          <a:ln/>
-        </p:spPr>
-      </p:sp>
-      <p:pic>
-        <p:nvPicPr>
-          <p:cNvPr id="18" name="Factor icon Agreement" descr="preencoded.png">    </p:cNvPr>
-          <p:cNvPicPr>
-            <a:picLocks noChangeAspect="1"/>
-          </p:cNvPicPr>
-          <p:nvPr/>
-        </p:nvPicPr>
-        <p:blipFill>
-          <a:blip r:embed="rId4"/>
-          <a:stretch>
-            <a:fillRect/>
-          </a:stretch>
-        </p:blipFill>
-        <p:spPr>
-          <a:xfrm>
-            <a:off x="6705600" y="4556760"/>
-            <a:ext cx="396240" cy="396240"/>
-          </a:xfrm>
-          <a:prstGeom prst="rect">
-            <a:avLst/>
-          </a:prstGeom>
-        </p:spPr>
-      </p:pic>
-      <p:sp>
-        <p:nvSpPr>
-          <p:cNvPr id="19" name="Factor text Agreement"/>
-          <p:cNvSpPr txBox="1"/>
-          <p:nvPr/>
-        </p:nvSpPr>
-        <p:spPr>
-          <a:xfrm>
-            <a:off x="7589520" y="4297680"/>
-            <a:ext cx="3810000" cy="1219200"/>
-          </a:xfrm>
-          <a:prstGeom prst="rect">
-            <a:avLst/>
-          </a:prstGeom>
-          <a:noFill/>
-          <a:ln/>
-        </p:spPr>
-        <p:txBody>
-          <a:bodyPr wrap="square" lIns="0" tIns="0" rIns="0" bIns="0" rtlCol="0" anchor="t"/>
-          <a:lstStyle/>
-          <a:p>
-            <a:pPr indent="0" marL="0">
-              <a:spcAft>
-                <a:spcPts val="600"/>
-              </a:spcAft>
-              <a:buNone/>
-            </a:pPr>
-            <a:r>
-              <a:rPr lang="en-US" sz="1800" b="1" dirty="0">
-                <a:solidFill>
-                  <a:schemeClr val="tx1"/>
-                </a:solidFill>
-              </a:rPr>
-              <a:t>Agreement</a:t>
-            </a:r>
-            <a:endParaRPr lang="en-US" sz="1800" dirty="0"/>
-          </a:p>
-          <a:p>
-            <a:pPr indent="0" marL="0">
-              <a:spcAft>
-                <a:spcPts val="600"/>
-              </a:spcAft>
-              <a:buNone/>
-            </a:pPr>
-            <a:r>
-              <a:rPr lang="en-US" sz="1260" dirty="0">
-                <a:solidFill>
-                  <a:schemeClr val="accent6"/>
-                </a:solidFill>
-              </a:rPr>
-              <a:t>Conflicting sources lower trust. Too low? Finn asks the owner</a:t>
-            </a:r>
-            <a:endParaRPr lang="en-US" sz="1800" dirty="0"/>
-          </a:p>
-        </p:txBody>
-      </p:sp>
-      <p:sp>
-        <p:nvSpPr>
-          <p:cNvPr id="25" name="Slide Number Placeholder 0"/>
-          <p:cNvSpPr>
-            <a:spLocks noGrp="1"/>
-          </p:cNvSpPr>
-          <p:nvPr>
-            <p:ph type="sldNum" sz="quarter" idx="4294967295"/>
-          </p:nvPr>
-        </p:nvSpPr>
-        <p:spPr>
-          <a:xfrm>
-            <a:off x="11338560" y="6355080"/>
-            <a:ext cx="457200" cy="274320"/>
-          </a:xfrm>
-          <a:prstGeom prst="rect">
-            <a:avLst/>
-          </a:prstGeom>
-          <a:extLst>
-            <a:ext uri="{C572A759-6A51-4108-AA02-DFA0A04FC94B}">
-              <ma14:wrappingTextBoxFlag xmlns:ma14="http://schemas.microsoft.com/office/mac/drawingml/2011/main" val="0"/>
-            </a:ext>
-          </a:extLst>
-        </p:spPr>
-        <p:txBody>
-          <a:bodyPr/>
-          <a:lstStyle>
-            <a:lvl1pPr>
-              <a:defRPr sz="900">
-                <a:solidFill>
-                  <a:schemeClr val="accent6"/>
-                </a:solidFill>
-              </a:defRPr>
-            </a:lvl1pPr>
-          </a:lstStyle>
-          <a:p>
-            <a:pPr algn="r"/>
-            <a:fld id="{F7021451-1387-4CA6-816F-3879F97B5CBC}" type="slidenum">
-              <a:rPr b="0" lang="en-US"/>
-              <a:t>8</a:t>
-            </a:fld>
-            <a:endParaRPr lang="en-US"/>
-          </a:p>
-        </p:txBody>
-      </p:sp>
-    </p:spTree>
-  </p:cSld>
-  <p:clrMapOvr>
-    <a:masterClrMapping/>
-  </p:clrMapOvr>
-  <p:transition spd="med">
-    <p:fade/>
-  </p:transition>
 </p:sld>
 </file>
 

</xml_diff>

<commit_message>
Pitch call: Roy holds the October answer, Finn updates the CRM
Keep "only in Roy's head" consistent: Finn calls Roy about October, Roy
gives the 22nd, Finn says he will update the CRM himself and Roy thanks
him. Slide 3's answer card shows "Confirmed by Roy" instead of a CRM
source. New audio for Finn's two lines.

Co-Authored-By: Claude Opus 5.5 <noreply@anthropic.com>
</commit_message>
<xml_diff>
--- a/docs/pitch/SDtrust-pitch.pptx
+++ b/docs/pitch/SDtrust-pitch.pptx
@@ -116,18 +116,18 @@
   <p:extLst>
     <p:ext uri="{521415D9-36F7-43E2-AB2F-B90AF26B5E84}">
       <p14:sectionLst xmlns:p14="http://schemas.microsoft.com/office/powerpoint/2010/main">
-        <p14:section name="Problem" id="{9798249d-9cf1-c418-31db-ed59db840723}">
+        <p14:section name="Problem" id="{8557aeb6-463d-5107-4031-dbc81e7ae753}">
           <p14:sldIdLst>
             <p14:sldId id="256"/>
             <p14:sldId id="257"/>
           </p14:sldIdLst>
         </p14:section>
-        <p14:section name="Solution" id="{6d56a0c0-520e-02b6-54e1-5373d2f09c01}">
+        <p14:section name="Solution" id="{b8d2b627-96e7-b06c-6720-f43f50900658}">
           <p14:sldIdLst>
             <p14:sldId id="258"/>
           </p14:sldIdLst>
         </p14:section>
-        <p14:section name="Demo" id="{98493e58-c801-0002-400b-7c0968f4643e}">
+        <p14:section name="Demo" id="{81d62c12-02e1-277a-0649-fcf93f7d2251}">
           <p14:sldIdLst>
             <p14:sldId id="259"/>
             <p14:sldId id="260"/>
@@ -135,12 +135,12 @@
             <p14:sldId id="262"/>
           </p14:sldIdLst>
         </p14:section>
-        <p14:section name="Call" id="{2b8078bd-2bbf-c8e7-2e8b-7c9cf30514b5}">
+        <p14:section name="Call" id="{a62fd9da-195c-3b6f-86f8-96ea6e9416b5}">
           <p14:sldIdLst>
             <p14:sldId id="263"/>
           </p14:sldIdLst>
         </p14:section>
-        <p14:section name="Close" id="{9c24aa10-65af-7685-0e58-1fc2e466b92c}">
+        <p14:section name="Close" id="{e37d2643-65ee-29a8-2819-7fb27bc84aaf}">
           <p14:sldIdLst>
             <p14:sldId id="264"/>
             <p14:sldId id="265"/>
@@ -1258,12 +1258,14 @@
               <a:rPr lang="en-US" dirty="0"/>
               <a:t>THE CALL. Roy stands up holding his phone as if he picks up.
 On entering: the call rings for 2 seconds, then Finn speaks (audio plays by itself):
-  FINN: Hi Roy, it's Finn. You own the Atlas agreements, so you're the one who knows. Until when can Atlas submit payroll changes in November? I can't find anything approved.
+  FINN: Hi Roy, it's Finn. You own the Atlas account, so you're the one who knows. Until when can Atlas submit payroll changes this October? I can't find anything approved.
 CLICK 1, Roy answers live, loud and clear:
-  ROY: Hi Finn! Until the 24th, same deal as October. I just forgot to put it in the CRM.
+  ROY: Hi Finn! Until the 22nd. I agreed it with Atlas, but I never put it in the CRM.
 CLICK 2, Finn answers (audio):
-  FINN: Thanks Roy! I've saved it, and I'll let Lotte know.
-CLICK 3, the knowledge card appears. PRESENTER: Roy never opened the CRM. Finn saved his answer from the call, so the next person who asks gets it straight away.</a:t>
+  FINN: Got it. I'll update the CRM myself, and let Lotte know.
+CLICK 3, Roy answers live:
+  ROY: Thanks, Finn!
+CLICK 4, the CRM card appears. PRESENTER: Roy never opened the CRM. Finn wrote the agreement there himself, so the next person who asks gets the 22nd straight away.</a:t>
             </a:r>
             <a:endParaRPr lang="en-US" dirty="0"/>
           </a:p>
@@ -4356,7 +4358,7 @@
                   <a:schemeClr val="accent4"/>
                 </a:solidFill>
               </a:rPr>
-              <a:t>Trust 92%</a:t>
+              <a:t>Confirmed by Roy</a:t>
             </a:r>
             <a:endParaRPr lang="en-US" sz="900" dirty="0"/>
           </a:p>
@@ -4373,7 +4375,7 @@
                   <a:schemeClr val="accent6"/>
                 </a:solidFill>
               </a:rPr>
-              <a:t>Source: CRM · Roy</a:t>
+              <a:t>Account owner, Atlas</a:t>
             </a:r>
             <a:endParaRPr lang="en-US" sz="900" dirty="0"/>
           </a:p>
@@ -6665,7 +6667,7 @@
                   <a:schemeClr val="bg2"/>
                 </a:solidFill>
               </a:rPr>
-              <a:t>He owns the Atlas agreements and approved the October exception</a:t>
+              <a:t>He is the Atlas account owner in the CRM</a:t>
             </a:r>
             <a:endParaRPr lang="en-US" sz="1020" dirty="0"/>
           </a:p>
@@ -6761,7 +6763,7 @@
                   <a:schemeClr val="bg1"/>
                 </a:solidFill>
               </a:rPr>
-              <a:t>Hi Roy, it's Finn. You own the Atlas agreements, so you're the one who knows. Until when can Atlas submit payroll changes in November? I can't find anything approved.</a:t>
+              <a:t>Hi Roy, it's Finn. You own the Atlas account, so you're the one who knows. Until when can Atlas submit payroll changes this October? I can't find anything approved.</a:t>
             </a:r>
             <a:endParaRPr lang="en-US" sz="900" dirty="0"/>
           </a:p>
@@ -6821,7 +6823,7 @@
                   <a:schemeClr val="bg1"/>
                 </a:solidFill>
               </a:rPr>
-              <a:t>Hi Finn! Until the 24th, same deal as October. I just forgot to put it in the CRM.</a:t>
+              <a:t>Hi Finn! Until the 22nd. I agreed it with Atlas, but I never put it in the CRM.</a:t>
             </a:r>
             <a:endParaRPr lang="en-US" sz="900" dirty="0"/>
           </a:p>
@@ -6881,7 +6883,7 @@
                   <a:schemeClr val="bg1"/>
                 </a:solidFill>
               </a:rPr>
-              <a:t>Thanks Roy! I've saved it, and I'll let Lotte know.</a:t>
+              <a:t>Got it. I'll update the CRM myself, and let Lotte know.</a:t>
             </a:r>
             <a:endParaRPr lang="en-US" sz="900" dirty="0"/>
           </a:p>
@@ -6889,7 +6891,67 @@
       </p:sp>
       <p:sp>
         <p:nvSpPr>
-          <p:cNvPr id="24" name="Knowledge card"/>
+          <p:cNvPr id="24" name="Bubble Roy 2"/>
+          <p:cNvSpPr/>
+          <p:nvPr/>
+        </p:nvSpPr>
+        <p:spPr>
+          <a:xfrm>
+            <a:off x="8595360" y="4724400"/>
+            <a:ext cx="3048000" cy="533400"/>
+          </a:xfrm>
+          <a:prstGeom prst="roundRect">
+            <a:avLst>
+              <a:gd name="adj" fmla="val 25714"/>
+            </a:avLst>
+          </a:prstGeom>
+          <a:solidFill>
+            <a:schemeClr val="accent1"/>
+          </a:solidFill>
+          <a:ln/>
+        </p:spPr>
+        <p:txBody>
+          <a:bodyPr wrap="square" lIns="127000" tIns="127000" rIns="127000" bIns="127000" rtlCol="0" anchor="ctr"/>
+          <a:lstStyle/>
+          <a:p>
+            <a:pPr indent="0" marL="0">
+              <a:spcAft>
+                <a:spcPts val="200"/>
+              </a:spcAft>
+              <a:buNone/>
+            </a:pPr>
+            <a:r>
+              <a:rPr lang="en-US" sz="900" b="1" dirty="0">
+                <a:solidFill>
+                  <a:schemeClr val="bg1"/>
+                </a:solidFill>
+              </a:rPr>
+              <a:t>Roy</a:t>
+            </a:r>
+            <a:endParaRPr lang="en-US" sz="900" dirty="0"/>
+          </a:p>
+          <a:p>
+            <a:pPr indent="0" marL="0">
+              <a:spcAft>
+                <a:spcPts val="200"/>
+              </a:spcAft>
+              <a:buNone/>
+            </a:pPr>
+            <a:r>
+              <a:rPr lang="en-US" sz="1260" dirty="0">
+                <a:solidFill>
+                  <a:schemeClr val="bg1"/>
+                </a:solidFill>
+              </a:rPr>
+              <a:t>Thanks, Finn!</a:t>
+            </a:r>
+            <a:endParaRPr lang="en-US" sz="900" dirty="0"/>
+          </a:p>
+        </p:txBody>
+      </p:sp>
+      <p:sp>
+        <p:nvSpPr>
+          <p:cNvPr id="25" name="Knowledge card"/>
           <p:cNvSpPr/>
           <p:nvPr/>
         </p:nvSpPr>
@@ -6916,7 +6978,7 @@
       </p:sp>
       <p:pic>
         <p:nvPicPr>
-          <p:cNvPr id="25" name="Knowledge icon" descr="preencoded.png">    </p:cNvPr>
+          <p:cNvPr id="26" name="Knowledge icon" descr="preencoded.png">    </p:cNvPr>
           <p:cNvPicPr>
             <a:picLocks noChangeAspect="1"/>
           </p:cNvPicPr>
@@ -6940,7 +7002,7 @@
       </p:pic>
       <p:sp>
         <p:nvSpPr>
-          <p:cNvPr id="26" name="Knowledge head"/>
+          <p:cNvPr id="27" name="Knowledge head"/>
           <p:cNvSpPr txBox="1"/>
           <p:nvPr/>
         </p:nvSpPr>
@@ -6968,7 +7030,7 @@
                   <a:schemeClr val="tx1"/>
                 </a:solidFill>
               </a:rPr>
-              <a:t>Added to Finn's knowledge, automatically</a:t>
+              <a:t>Saved to the CRM by Finn</a:t>
             </a:r>
             <a:endParaRPr lang="en-US" sz="1260" dirty="0"/>
           </a:p>
@@ -6976,7 +7038,7 @@
       </p:sp>
       <p:sp>
         <p:nvSpPr>
-          <p:cNvPr id="27" name="Knowledge source"/>
+          <p:cNvPr id="28" name="Knowledge source"/>
           <p:cNvSpPr txBox="1"/>
           <p:nvPr/>
         </p:nvSpPr>
@@ -7004,7 +7066,7 @@
                   <a:schemeClr val="accent6"/>
                 </a:solidFill>
               </a:rPr>
-              <a:t>S35 · Teams call · Roy · 21 October 2026</a:t>
+              <a:t>S35 · Teams call with Roy · 21 October 2026</a:t>
             </a:r>
             <a:endParaRPr lang="en-US" sz="900" dirty="0"/>
           </a:p>
@@ -7012,7 +7074,7 @@
       </p:sp>
       <p:sp>
         <p:nvSpPr>
-          <p:cNvPr id="28" name="Knowledge quote"/>
+          <p:cNvPr id="29" name="Knowledge quote"/>
           <p:cNvSpPr txBox="1"/>
           <p:nvPr/>
         </p:nvSpPr>
@@ -7040,7 +7102,7 @@
                   <a:schemeClr val="tx1"/>
                 </a:solidFill>
               </a:rPr>
-              <a:t>“Atlas may submit payroll changes until 24 November 2026.”</a:t>
+              <a:t>“Atlas may submit payroll changes until 22 October 2026.”</a:t>
             </a:r>
             <a:endParaRPr lang="en-US" sz="1380" dirty="0"/>
           </a:p>
@@ -7048,7 +7110,7 @@
       </p:sp>
       <p:sp>
         <p:nvSpPr>
-          <p:cNvPr id="29" name="Chip owner"/>
+          <p:cNvPr id="30" name="Chip owner"/>
           <p:cNvSpPr/>
           <p:nvPr/>
         </p:nvSpPr>
@@ -7088,7 +7150,7 @@
       </p:sp>
       <p:sp>
         <p:nvSpPr>
-          <p:cNvPr id="30" name="Chip scope"/>
+          <p:cNvPr id="31" name="Chip scope"/>
           <p:cNvSpPr/>
           <p:nvPr/>
         </p:nvSpPr>
@@ -7120,7 +7182,7 @@
                   <a:schemeClr val="tx1"/>
                 </a:solidFill>
               </a:rPr>
-              <a:t>Belgium · Atlas · November 2026</a:t>
+              <a:t>Belgium · Atlas · October 2026</a:t>
             </a:r>
             <a:endParaRPr lang="en-US" sz="900" dirty="0"/>
           </a:p>
@@ -7128,7 +7190,7 @@
       </p:sp>
       <p:sp>
         <p:nvSpPr>
-          <p:cNvPr id="31" name="Trust label"/>
+          <p:cNvPr id="32" name="Trust label"/>
           <p:cNvSpPr txBox="1"/>
           <p:nvPr/>
         </p:nvSpPr>
@@ -7175,7 +7237,7 @@
       </p:sp>
       <p:sp>
         <p:nvSpPr>
-          <p:cNvPr id="32" name="Trust value"/>
+          <p:cNvPr id="33" name="Trust value"/>
           <p:cNvSpPr txBox="1"/>
           <p:nvPr/>
         </p:nvSpPr>
@@ -7211,7 +7273,7 @@
       </p:sp>
       <p:sp>
         <p:nvSpPr>
-          <p:cNvPr id="33" name="Meter bg"/>
+          <p:cNvPr id="34" name="Meter bg"/>
           <p:cNvSpPr/>
           <p:nvPr/>
         </p:nvSpPr>
@@ -7233,7 +7295,7 @@
       </p:sp>
       <p:sp>
         <p:nvSpPr>
-          <p:cNvPr id="34" name="Meter fill"/>
+          <p:cNvPr id="35" name="Meter fill"/>
           <p:cNvSpPr/>
           <p:nvPr/>
         </p:nvSpPr>
@@ -7255,7 +7317,7 @@
       </p:sp>
       <p:pic>
         <p:nvPicPr>
-          <p:cNvPr id="38" name="Finn audio 1"/>
+          <p:cNvPr id="39" name="Finn audio 1"/>
           <p:cNvPicPr>
             <a:picLocks noChangeAspect="1"/>
           </p:cNvPicPr>
@@ -7286,7 +7348,7 @@
       </p:pic>
       <p:pic>
         <p:nvPicPr>
-          <p:cNvPr id="39" name="Finn audio 2"/>
+          <p:cNvPr id="40" name="Finn audio 2"/>
           <p:cNvPicPr>
             <a:picLocks noChangeAspect="1"/>
           </p:cNvPicPr>
@@ -7317,7 +7379,7 @@
       </p:pic>
       <p:sp>
         <p:nvSpPr>
-          <p:cNvPr id="37" name="Slide Number Placeholder 0"/>
+          <p:cNvPr id="38" name="Slide Number Placeholder 0"/>
           <p:cNvSpPr>
             <a:spLocks noGrp="1"/>
           </p:cNvSpPr>
@@ -7644,9 +7706,9 @@
                                   <p:childTnLst>
                                     <p:cmd type="call" cmd="playFrom(0.0)">
                                       <p:cBhvr>
-                                        <p:cTn id="27" dur="10368" fill="hold"/>
-                                        <p:tgtEl>
-                                          <p:spTgt spid="38"/>
+                                        <p:cTn id="27" dur="10176" fill="hold"/>
+                                        <p:tgtEl>
+                                          <p:spTgt spid="39"/>
                                         </p:tgtEl>
                                       </p:cBhvr>
                                     </p:cmd>
@@ -7843,9 +7905,9 @@
                                   <p:childTnLst>
                                     <p:cmd type="call" cmd="playFrom(0.0)">
                                       <p:cBhvr>
-                                        <p:cTn id="41" dur="3216" fill="hold"/>
-                                        <p:tgtEl>
-                                          <p:spTgt spid="39"/>
+                                        <p:cTn id="41" dur="3888" fill="hold"/>
+                                        <p:tgtEl>
+                                          <p:spTgt spid="40"/>
                                         </p:tgtEl>
                                       </p:cBhvr>
                                     </p:cmd>
@@ -7871,7 +7933,7 @@
                             </p:stCondLst>
                             <p:childTnLst>
                               <p:par>
-                                <p:cTn id="44" presetID="10" presetClass="entr" presetSubtype="0" fill="hold" grpId="0" nodeType="clickEffect">
+                                <p:cTn id="44" presetID="2" presetClass="entr" presetSubtype="4" fill="hold" grpId="0" nodeType="clickEffect">
                                   <p:stCondLst>
                                     <p:cond delay="0"/>
                                   </p:stCondLst>
@@ -7894,26 +7956,82 @@
                                         <p:strVal val="visible"/>
                                       </p:to>
                                     </p:set>
-                                    <p:animEffect transition="in" filter="fade">
-                                      <p:cBhvr>
-                                        <p:cTn id="46" dur="500"/>
+                                    <p:anim calcmode="lin" valueType="num">
+                                      <p:cBhvr additive="base">
+                                        <p:cTn id="46" dur="500" fill="hold"/>
                                         <p:tgtEl>
                                           <p:spTgt spid="24"/>
                                         </p:tgtEl>
-                                      </p:cBhvr>
-                                    </p:animEffect>
+                                        <p:attrNameLst>
+                                          <p:attrName>ppt_x</p:attrName>
+                                        </p:attrNameLst>
+                                      </p:cBhvr>
+                                      <p:tavLst>
+                                        <p:tav tm="0">
+                                          <p:val>
+                                            <p:strVal val="#ppt_x"/>
+                                          </p:val>
+                                        </p:tav>
+                                        <p:tav tm="100000">
+                                          <p:val>
+                                            <p:strVal val="#ppt_x"/>
+                                          </p:val>
+                                        </p:tav>
+                                      </p:tavLst>
+                                    </p:anim>
+                                    <p:anim calcmode="lin" valueType="num">
+                                      <p:cBhvr additive="base">
+                                        <p:cTn id="47" dur="500" fill="hold"/>
+                                        <p:tgtEl>
+                                          <p:spTgt spid="24"/>
+                                        </p:tgtEl>
+                                        <p:attrNameLst>
+                                          <p:attrName>ppt_y</p:attrName>
+                                        </p:attrNameLst>
+                                      </p:cBhvr>
+                                      <p:tavLst>
+                                        <p:tav tm="0">
+                                          <p:val>
+                                            <p:strVal val="1+#ppt_h/2"/>
+                                          </p:val>
+                                        </p:tav>
+                                        <p:tav tm="100000">
+                                          <p:val>
+                                            <p:strVal val="#ppt_y"/>
+                                          </p:val>
+                                        </p:tav>
+                                      </p:tavLst>
+                                    </p:anim>
                                   </p:childTnLst>
                                 </p:cTn>
                               </p:par>
+                            </p:childTnLst>
+                          </p:cTn>
+                        </p:par>
+                      </p:childTnLst>
+                    </p:cTn>
+                  </p:par>
+                  <p:par>
+                    <p:cTn id="48" fill="hold">
+                      <p:stCondLst>
+                        <p:cond delay="indefinite"/>
+                      </p:stCondLst>
+                      <p:childTnLst>
+                        <p:par>
+                          <p:cTn id="49" fill="hold">
+                            <p:stCondLst>
+                              <p:cond delay="0"/>
+                            </p:stCondLst>
+                            <p:childTnLst>
                               <p:par>
-                                <p:cTn id="47" presetID="10" presetClass="entr" presetSubtype="0" fill="hold" grpId="0" nodeType="withEffect">
+                                <p:cTn id="50" presetID="10" presetClass="entr" presetSubtype="0" fill="hold" grpId="0" nodeType="clickEffect">
                                   <p:stCondLst>
                                     <p:cond delay="0"/>
                                   </p:stCondLst>
                                   <p:childTnLst>
                                     <p:set>
                                       <p:cBhvr>
-                                        <p:cTn id="48" dur="1" fill="hold">
+                                        <p:cTn id="51" dur="1" fill="hold">
                                           <p:stCondLst>
                                             <p:cond delay="0"/>
                                           </p:stCondLst>
@@ -7931,44 +8049,9 @@
                                     </p:set>
                                     <p:animEffect transition="in" filter="fade">
                                       <p:cBhvr>
-                                        <p:cTn id="49" dur="500"/>
+                                        <p:cTn id="52" dur="500"/>
                                         <p:tgtEl>
                                           <p:spTgt spid="25"/>
-                                        </p:tgtEl>
-                                      </p:cBhvr>
-                                    </p:animEffect>
-                                  </p:childTnLst>
-                                </p:cTn>
-                              </p:par>
-                              <p:par>
-                                <p:cTn id="50" presetID="10" presetClass="entr" presetSubtype="0" fill="hold" grpId="0" nodeType="withEffect">
-                                  <p:stCondLst>
-                                    <p:cond delay="0"/>
-                                  </p:stCondLst>
-                                  <p:childTnLst>
-                                    <p:set>
-                                      <p:cBhvr>
-                                        <p:cTn id="51" dur="1" fill="hold">
-                                          <p:stCondLst>
-                                            <p:cond delay="0"/>
-                                          </p:stCondLst>
-                                        </p:cTn>
-                                        <p:tgtEl>
-                                          <p:spTgt spid="26"/>
-                                        </p:tgtEl>
-                                        <p:attrNameLst>
-                                          <p:attrName>style.visibility</p:attrName>
-                                        </p:attrNameLst>
-                                      </p:cBhvr>
-                                      <p:to>
-                                        <p:strVal val="visible"/>
-                                      </p:to>
-                                    </p:set>
-                                    <p:animEffect transition="in" filter="fade">
-                                      <p:cBhvr>
-                                        <p:cTn id="52" dur="500"/>
-                                        <p:tgtEl>
-                                          <p:spTgt spid="26"/>
                                         </p:tgtEl>
                                       </p:cBhvr>
                                     </p:animEffect>
@@ -7989,7 +8072,7 @@
                                           </p:stCondLst>
                                         </p:cTn>
                                         <p:tgtEl>
-                                          <p:spTgt spid="27"/>
+                                          <p:spTgt spid="26"/>
                                         </p:tgtEl>
                                         <p:attrNameLst>
                                           <p:attrName>style.visibility</p:attrName>
@@ -8003,7 +8086,7 @@
                                       <p:cBhvr>
                                         <p:cTn id="55" dur="500"/>
                                         <p:tgtEl>
-                                          <p:spTgt spid="27"/>
+                                          <p:spTgt spid="26"/>
                                         </p:tgtEl>
                                       </p:cBhvr>
                                     </p:animEffect>
@@ -8024,7 +8107,7 @@
                                           </p:stCondLst>
                                         </p:cTn>
                                         <p:tgtEl>
-                                          <p:spTgt spid="28"/>
+                                          <p:spTgt spid="27"/>
                                         </p:tgtEl>
                                         <p:attrNameLst>
                                           <p:attrName>style.visibility</p:attrName>
@@ -8038,7 +8121,7 @@
                                       <p:cBhvr>
                                         <p:cTn id="58" dur="500"/>
                                         <p:tgtEl>
-                                          <p:spTgt spid="28"/>
+                                          <p:spTgt spid="27"/>
                                         </p:tgtEl>
                                       </p:cBhvr>
                                     </p:animEffect>
@@ -8059,7 +8142,7 @@
                                           </p:stCondLst>
                                         </p:cTn>
                                         <p:tgtEl>
-                                          <p:spTgt spid="29"/>
+                                          <p:spTgt spid="28"/>
                                         </p:tgtEl>
                                         <p:attrNameLst>
                                           <p:attrName>style.visibility</p:attrName>
@@ -8073,7 +8156,7 @@
                                       <p:cBhvr>
                                         <p:cTn id="61" dur="500"/>
                                         <p:tgtEl>
-                                          <p:spTgt spid="29"/>
+                                          <p:spTgt spid="28"/>
                                         </p:tgtEl>
                                       </p:cBhvr>
                                     </p:animEffect>
@@ -8094,7 +8177,7 @@
                                           </p:stCondLst>
                                         </p:cTn>
                                         <p:tgtEl>
-                                          <p:spTgt spid="30"/>
+                                          <p:spTgt spid="29"/>
                                         </p:tgtEl>
                                         <p:attrNameLst>
                                           <p:attrName>style.visibility</p:attrName>
@@ -8108,7 +8191,7 @@
                                       <p:cBhvr>
                                         <p:cTn id="64" dur="500"/>
                                         <p:tgtEl>
-                                          <p:spTgt spid="30"/>
+                                          <p:spTgt spid="29"/>
                                         </p:tgtEl>
                                       </p:cBhvr>
                                     </p:animEffect>
@@ -8129,7 +8212,7 @@
                                           </p:stCondLst>
                                         </p:cTn>
                                         <p:tgtEl>
-                                          <p:spTgt spid="31"/>
+                                          <p:spTgt spid="30"/>
                                         </p:tgtEl>
                                         <p:attrNameLst>
                                           <p:attrName>style.visibility</p:attrName>
@@ -8143,7 +8226,7 @@
                                       <p:cBhvr>
                                         <p:cTn id="67" dur="500"/>
                                         <p:tgtEl>
-                                          <p:spTgt spid="31"/>
+                                          <p:spTgt spid="30"/>
                                         </p:tgtEl>
                                       </p:cBhvr>
                                     </p:animEffect>
@@ -8164,7 +8247,7 @@
                                           </p:stCondLst>
                                         </p:cTn>
                                         <p:tgtEl>
-                                          <p:spTgt spid="32"/>
+                                          <p:spTgt spid="31"/>
                                         </p:tgtEl>
                                         <p:attrNameLst>
                                           <p:attrName>style.visibility</p:attrName>
@@ -8178,7 +8261,7 @@
                                       <p:cBhvr>
                                         <p:cTn id="70" dur="500"/>
                                         <p:tgtEl>
-                                          <p:spTgt spid="32"/>
+                                          <p:spTgt spid="31"/>
                                         </p:tgtEl>
                                       </p:cBhvr>
                                     </p:animEffect>
@@ -8199,7 +8282,7 @@
                                           </p:stCondLst>
                                         </p:cTn>
                                         <p:tgtEl>
-                                          <p:spTgt spid="33"/>
+                                          <p:spTgt spid="32"/>
                                         </p:tgtEl>
                                         <p:attrNameLst>
                                           <p:attrName>style.visibility</p:attrName>
@@ -8213,7 +8296,7 @@
                                       <p:cBhvr>
                                         <p:cTn id="73" dur="500"/>
                                         <p:tgtEl>
-                                          <p:spTgt spid="33"/>
+                                          <p:spTgt spid="32"/>
                                         </p:tgtEl>
                                       </p:cBhvr>
                                     </p:animEffect>
@@ -8221,20 +8304,90 @@
                                 </p:cTn>
                               </p:par>
                               <p:par>
-                                <p:cTn id="74" presetID="22" presetClass="entr" presetSubtype="8" fill="hold" grpId="0" nodeType="withEffect">
+                                <p:cTn id="74" presetID="10" presetClass="entr" presetSubtype="0" fill="hold" grpId="0" nodeType="withEffect">
+                                  <p:stCondLst>
+                                    <p:cond delay="0"/>
+                                  </p:stCondLst>
+                                  <p:childTnLst>
+                                    <p:set>
+                                      <p:cBhvr>
+                                        <p:cTn id="75" dur="1" fill="hold">
+                                          <p:stCondLst>
+                                            <p:cond delay="0"/>
+                                          </p:stCondLst>
+                                        </p:cTn>
+                                        <p:tgtEl>
+                                          <p:spTgt spid="33"/>
+                                        </p:tgtEl>
+                                        <p:attrNameLst>
+                                          <p:attrName>style.visibility</p:attrName>
+                                        </p:attrNameLst>
+                                      </p:cBhvr>
+                                      <p:to>
+                                        <p:strVal val="visible"/>
+                                      </p:to>
+                                    </p:set>
+                                    <p:animEffect transition="in" filter="fade">
+                                      <p:cBhvr>
+                                        <p:cTn id="76" dur="500"/>
+                                        <p:tgtEl>
+                                          <p:spTgt spid="33"/>
+                                        </p:tgtEl>
+                                      </p:cBhvr>
+                                    </p:animEffect>
+                                  </p:childTnLst>
+                                </p:cTn>
+                              </p:par>
+                              <p:par>
+                                <p:cTn id="77" presetID="10" presetClass="entr" presetSubtype="0" fill="hold" grpId="0" nodeType="withEffect">
+                                  <p:stCondLst>
+                                    <p:cond delay="0"/>
+                                  </p:stCondLst>
+                                  <p:childTnLst>
+                                    <p:set>
+                                      <p:cBhvr>
+                                        <p:cTn id="78" dur="1" fill="hold">
+                                          <p:stCondLst>
+                                            <p:cond delay="0"/>
+                                          </p:stCondLst>
+                                        </p:cTn>
+                                        <p:tgtEl>
+                                          <p:spTgt spid="34"/>
+                                        </p:tgtEl>
+                                        <p:attrNameLst>
+                                          <p:attrName>style.visibility</p:attrName>
+                                        </p:attrNameLst>
+                                      </p:cBhvr>
+                                      <p:to>
+                                        <p:strVal val="visible"/>
+                                      </p:to>
+                                    </p:set>
+                                    <p:animEffect transition="in" filter="fade">
+                                      <p:cBhvr>
+                                        <p:cTn id="79" dur="500"/>
+                                        <p:tgtEl>
+                                          <p:spTgt spid="34"/>
+                                        </p:tgtEl>
+                                      </p:cBhvr>
+                                    </p:animEffect>
+                                  </p:childTnLst>
+                                </p:cTn>
+                              </p:par>
+                              <p:par>
+                                <p:cTn id="80" presetID="22" presetClass="entr" presetSubtype="8" fill="hold" grpId="0" nodeType="withEffect">
                                   <p:stCondLst>
                                     <p:cond delay="500"/>
                                   </p:stCondLst>
                                   <p:childTnLst>
                                     <p:set>
                                       <p:cBhvr>
-                                        <p:cTn id="75" dur="1" fill="hold">
+                                        <p:cTn id="81" dur="1" fill="hold">
                                           <p:stCondLst>
                                             <p:cond delay="0"/>
                                           </p:stCondLst>
                                         </p:cTn>
                                         <p:tgtEl>
-                                          <p:spTgt spid="34"/>
+                                          <p:spTgt spid="35"/>
                                         </p:tgtEl>
                                         <p:attrNameLst>
                                           <p:attrName>style.visibility</p:attrName>
@@ -8246,9 +8399,9 @@
                                     </p:set>
                                     <p:animEffect transition="in" filter="wipe(left)">
                                       <p:cBhvr>
-                                        <p:cTn id="76" dur="1400"/>
-                                        <p:tgtEl>
-                                          <p:spTgt spid="34"/>
+                                        <p:cTn id="82" dur="1400"/>
+                                        <p:tgtEl>
+                                          <p:spTgt spid="35"/>
                                         </p:tgtEl>
                                       </p:cBhvr>
                                     </p:animEffect>
@@ -8280,26 +8433,7 @@
             </p:seq>
             <p:audio>
               <p:cMediaNode vol="80000">
-                <p:cTn id="77" display="0" fill="hold">
-                  <p:stCondLst>
-                    <p:cond delay="indefinite"/>
-                  </p:stCondLst>
-                  <p:endCondLst>
-                    <p:cond evt="onStopAudio" delay="0">
-                      <p:tgtEl>
-                        <p:sldTgt/>
-                      </p:tgtEl>
-                    </p:cond>
-                  </p:endCondLst>
-                </p:cTn>
-                <p:tgtEl>
-                  <p:spTgt spid="38"/>
-                </p:tgtEl>
-              </p:cMediaNode>
-            </p:audio>
-            <p:audio>
-              <p:cMediaNode vol="80000">
-                <p:cTn id="78" display="0" fill="hold">
+                <p:cTn id="83" display="0" fill="hold">
                   <p:stCondLst>
                     <p:cond delay="indefinite"/>
                   </p:stCondLst>
@@ -8313,6 +8447,25 @@
                 </p:cTn>
                 <p:tgtEl>
                   <p:spTgt spid="39"/>
+                </p:tgtEl>
+              </p:cMediaNode>
+            </p:audio>
+            <p:audio>
+              <p:cMediaNode vol="80000">
+                <p:cTn id="84" display="0" fill="hold">
+                  <p:stCondLst>
+                    <p:cond delay="indefinite"/>
+                  </p:stCondLst>
+                  <p:endCondLst>
+                    <p:cond evt="onStopAudio" delay="0">
+                      <p:tgtEl>
+                        <p:sldTgt/>
+                      </p:tgtEl>
+                    </p:cond>
+                  </p:endCondLst>
+                </p:cTn>
+                <p:tgtEl>
+                  <p:spTgt spid="40"/>
                 </p:tgtEl>
               </p:cMediaNode>
             </p:audio>
@@ -8331,7 +8484,7 @@
       <p:bldP spid="22" grpId="0" animBg="1"/>
       <p:bldP spid="23" grpId="0" animBg="1"/>
       <p:bldP spid="24" grpId="0" animBg="1"/>
-      <p:bldP spid="26" grpId="0" animBg="1"/>
+      <p:bldP spid="25" grpId="0" animBg="1"/>
       <p:bldP spid="27" grpId="0" animBg="1"/>
       <p:bldP spid="28" grpId="0" animBg="1"/>
       <p:bldP spid="29" grpId="0" animBg="1"/>
@@ -8340,6 +8493,7 @@
       <p:bldP spid="32" grpId="0" animBg="1"/>
       <p:bldP spid="33" grpId="0" animBg="1"/>
       <p:bldP spid="34" grpId="0" animBg="1"/>
+      <p:bldP spid="35" grpId="0" animBg="1"/>
     </p:bldLst>
   </p:timing>
 </p:sld>

</xml_diff>

<commit_message>
Pitch deck: proud arms-crossed Finn on the thank-you slide
High-resolution proud Finn animation (blink and smile loop, made with
GPT-6.1-Sol) replaces the small waving sprite on the last slide of the
PowerPoint and both HTML decks.

Co-Authored-By: Claude Opus 5.5 <noreply@anthropic.com>
</commit_message>
<xml_diff>
--- a/docs/pitch/SDtrust-pitch.pptx
+++ b/docs/pitch/SDtrust-pitch.pptx
@@ -116,18 +116,18 @@
   <p:extLst>
     <p:ext uri="{521415D9-36F7-43E2-AB2F-B90AF26B5E84}">
       <p14:sectionLst xmlns:p14="http://schemas.microsoft.com/office/powerpoint/2010/main">
-        <p14:section name="Problem" id="{8557aeb6-463d-5107-4031-dbc81e7ae753}">
+        <p14:section name="Problem" id="{e7807f90-629d-d86c-f2fa-57a645bbe65b}">
           <p14:sldIdLst>
             <p14:sldId id="256"/>
             <p14:sldId id="257"/>
           </p14:sldIdLst>
         </p14:section>
-        <p14:section name="Solution" id="{b8d2b627-96e7-b06c-6720-f43f50900658}">
+        <p14:section name="Solution" id="{f2420705-dd6e-0e25-3f60-d7ab178fe7a3}">
           <p14:sldIdLst>
             <p14:sldId id="258"/>
           </p14:sldIdLst>
         </p14:section>
-        <p14:section name="Demo" id="{81d62c12-02e1-277a-0649-fcf93f7d2251}">
+        <p14:section name="Demo" id="{6d02414d-9cec-3ccf-e2de-abb5dd22d914}">
           <p14:sldIdLst>
             <p14:sldId id="259"/>
             <p14:sldId id="260"/>
@@ -135,12 +135,12 @@
             <p14:sldId id="262"/>
           </p14:sldIdLst>
         </p14:section>
-        <p14:section name="Call" id="{a62fd9da-195c-3b6f-86f8-96ea6e9416b5}">
+        <p14:section name="Call" id="{d6a85a07-5bb9-970b-85ee-1569dbdd7b1a}">
           <p14:sldIdLst>
             <p14:sldId id="263"/>
           </p14:sldIdLst>
         </p14:section>
-        <p14:section name="Close" id="{e37d2643-65ee-29a8-2819-7fb27bc84aaf}">
+        <p14:section name="Close" id="{67946816-167f-e07a-1b40-9254fb346def}">
           <p14:sldIdLst>
             <p14:sldId id="264"/>
             <p14:sldId id="265"/>
@@ -2607,7 +2607,7 @@
       </p:sp>
       <p:pic>
         <p:nvPicPr>
-          <p:cNvPr id="8" name="Finn waving" descr="/tmp/sdtrust-deck/gifs/finn-waving-big.gif">    </p:cNvPr>
+          <p:cNvPr id="8" name="Finn proud" descr="/tmp/sdtrust-deck/gifs/finn-proud.gif">    </p:cNvPr>
           <p:cNvPicPr>
             <a:picLocks noChangeAspect="1"/>
           </p:cNvPicPr>
@@ -2621,8 +2621,8 @@
         </p:blipFill>
         <p:spPr>
           <a:xfrm>
-            <a:off x="7924800" y="1524000"/>
-            <a:ext cx="2522220" cy="3962400"/>
+            <a:off x="8229600" y="1066800"/>
+            <a:ext cx="2560320" cy="4876800"/>
           </a:xfrm>
           <a:prstGeom prst="rect">
             <a:avLst/>

</xml_diff>